<commit_message>
Review fixes: dashboard redesign, checked LLM summary, corrected README
- Dashboard: one stylesheet, summary cards, risk pills, reason chips on
  the list, contribution bars, sparkline and stage bars.
- Optional LLM summary of each new briefing (app/jobs/narrate.py,
  migration 0005): runs after the night commits, sends only the reason
  list, rejects any number not in its input. Off without LLM_API_KEY.
- README: two-minute reviewer summary with screenshots; every claim the
  audit found unbacked is corrected (roles, clock, licences, oracle,
  model choice, baseline). docs/design-questions.md answers the
  walkthrough questions.
- Deck: screenshot slides and corrected wording. Loom script in two parts.

Co-Authored-By: Claude Opus 5.5 <noreply@anthropic.com>
</commit_message>
<xml_diff>
--- a/docs/deck.pptx
+++ b/docs/deck.pptx
@@ -14,9 +14,11 @@
     <p:sldId id="262" r:id="rId8"/>
     <p:sldId id="263" r:id="rId9"/>
     <p:sldId id="264" r:id="rId10"/>
+    <p:sldId id="265" r:id="rId11"/>
+    <p:sldId id="266" r:id="rId12"/>
   </p:sldIdLst>
   <p:notesMasterIdLst>
-    <p:notesMasterId r:id="rId11"/>
+    <p:notesMasterId r:id="rId13"/>
   </p:notesMasterIdLst>
   <p:sldSz cx="12192000" cy="6858000"/>
   <p:notesSz cx="6858000" cy="12192000"/>
@@ -208,7 +210,7 @@
                 <c:ptCount val="5"/>
                 <c:lvl>
                   <c:pt idx="0">
-                    <c:v>Oracle (latent health)</c:v>
+                    <c:v>Oracle (hidden health)</c:v>
                   </c:pt>
                   <c:pt idx="1">
                     <c:v>LightGBM (live)</c:v>
@@ -835,6 +837,182 @@
 </p:notes>
 </file>
 
+<file path=ppt/notesSlides/notesSlide10.xml><?xml version="1.0" encoding="utf-8"?>
+<p:notes xmlns:a="http://schemas.openxmlformats.org/drawingml/2006/main" xmlns:r="http://schemas.openxmlformats.org/officeDocument/2006/relationships" xmlns:p="http://schemas.openxmlformats.org/presentationml/2006/main">
+  <p:cSld>
+    <p:spTree>
+      <p:nvGrpSpPr>
+        <p:cNvPr id="1" name=""/>
+        <p:cNvGrpSpPr/>
+        <p:nvPr/>
+      </p:nvGrpSpPr>
+      <p:grpSpPr>
+        <a:xfrm>
+          <a:off x="0" y="0"/>
+          <a:ext cx="0" cy="0"/>
+          <a:chOff x="0" y="0"/>
+          <a:chExt cx="0" cy="0"/>
+        </a:xfrm>
+      </p:grpSpPr>
+      <p:sp>
+        <p:nvSpPr>
+          <p:cNvPr id="2" name="Slide Image Placeholder 1"/>
+          <p:cNvSpPr>
+            <a:spLocks noGrp="1" noRot="1" noChangeAspect="1"/>
+          </p:cNvSpPr>
+          <p:nvPr>
+            <p:ph type="sldImg"/>
+          </p:nvPr>
+        </p:nvSpPr>
+        <p:spPr/>
+      </p:sp>
+      <p:sp>
+        <p:nvSpPr>
+          <p:cNvPr id="3" name="Notes Placeholder 2"/>
+          <p:cNvSpPr>
+            <a:spLocks noGrp="1"/>
+          </p:cNvSpPr>
+          <p:nvPr>
+            <p:ph type="body" idx="1"/>
+          </p:nvPr>
+        </p:nvSpPr>
+        <p:spPr/>
+        <p:txBody>
+          <a:bodyPr/>
+          <a:lstStyle/>
+          <a:p>
+            <a:r>
+              <a:rPr lang="en-US" dirty="0"/>
+              <a:t>All of these are linear extrapolations from the live stage timings and a local memory profile, written up in docs/decisions/step-7-10x.md.</a:t>
+            </a:r>
+            <a:endParaRPr lang="en-US" dirty="0"/>
+          </a:p>
+        </p:txBody>
+      </p:sp>
+      <p:sp>
+        <p:nvSpPr>
+          <p:cNvPr id="4" name="Slide Number Placeholder 3"/>
+          <p:cNvSpPr>
+            <a:spLocks noGrp="1"/>
+          </p:cNvSpPr>
+          <p:nvPr>
+            <p:ph type="sldNum" sz="quarter" idx="10"/>
+          </p:nvPr>
+        </p:nvSpPr>
+        <p:spPr/>
+        <p:txBody>
+          <a:bodyPr/>
+          <a:lstStyle/>
+          <a:p>
+            <a:fld id="{F7021451-1387-4CA6-816F-3879F97B5CBC}" type="slidenum">
+              <a:rPr lang="en-US"/>
+              <a:t>10</a:t>
+            </a:fld>
+            <a:endParaRPr lang="en-US"/>
+          </a:p>
+        </p:txBody>
+      </p:sp>
+    </p:spTree>
+    <p:extLst>
+      <p:ext uri="{BB962C8B-B14F-4D97-AF65-F5344CB8AC3E}">
+        <p14:creationId xmlns:p14="http://schemas.microsoft.com/office/powerpoint/2010/main" val="1024086991"/>
+      </p:ext>
+    </p:extLst>
+  </p:cSld>
+  <p:clrMapOvr>
+    <a:masterClrMapping/>
+  </p:clrMapOvr>
+</p:notes>
+</file>
+
+<file path=ppt/notesSlides/notesSlide11.xml><?xml version="1.0" encoding="utf-8"?>
+<p:notes xmlns:a="http://schemas.openxmlformats.org/drawingml/2006/main" xmlns:r="http://schemas.openxmlformats.org/officeDocument/2006/relationships" xmlns:p="http://schemas.openxmlformats.org/presentationml/2006/main">
+  <p:cSld>
+    <p:spTree>
+      <p:nvGrpSpPr>
+        <p:cNvPr id="1" name=""/>
+        <p:cNvGrpSpPr/>
+        <p:nvPr/>
+      </p:nvGrpSpPr>
+      <p:grpSpPr>
+        <a:xfrm>
+          <a:off x="0" y="0"/>
+          <a:ext cx="0" cy="0"/>
+          <a:chOff x="0" y="0"/>
+          <a:chExt cx="0" cy="0"/>
+        </a:xfrm>
+      </p:grpSpPr>
+      <p:sp>
+        <p:nvSpPr>
+          <p:cNvPr id="2" name="Slide Image Placeholder 1"/>
+          <p:cNvSpPr>
+            <a:spLocks noGrp="1" noRot="1" noChangeAspect="1"/>
+          </p:cNvSpPr>
+          <p:nvPr>
+            <p:ph type="sldImg"/>
+          </p:nvPr>
+        </p:nvSpPr>
+        <p:spPr/>
+      </p:sp>
+      <p:sp>
+        <p:nvSpPr>
+          <p:cNvPr id="3" name="Notes Placeholder 2"/>
+          <p:cNvSpPr>
+            <a:spLocks noGrp="1"/>
+          </p:cNvSpPr>
+          <p:nvPr>
+            <p:ph type="body" idx="1"/>
+          </p:nvPr>
+        </p:nvSpPr>
+        <p:spPr/>
+        <p:txBody>
+          <a:bodyPr/>
+          <a:lstStyle/>
+          <a:p>
+            <a:r>
+              <a:rPr lang="en-US" dirty="0"/>
+              <a:t>The synthetic evaluation validates the mechanics. The first real-data step is to refit on actual renewals and see what the dismissal reasons say.</a:t>
+            </a:r>
+            <a:endParaRPr lang="en-US" dirty="0"/>
+          </a:p>
+        </p:txBody>
+      </p:sp>
+      <p:sp>
+        <p:nvSpPr>
+          <p:cNvPr id="4" name="Slide Number Placeholder 3"/>
+          <p:cNvSpPr>
+            <a:spLocks noGrp="1"/>
+          </p:cNvSpPr>
+          <p:nvPr>
+            <p:ph type="sldNum" sz="quarter" idx="10"/>
+          </p:nvPr>
+        </p:nvSpPr>
+        <p:spPr/>
+        <p:txBody>
+          <a:bodyPr/>
+          <a:lstStyle/>
+          <a:p>
+            <a:fld id="{F7021451-1387-4CA6-816F-3879F97B5CBC}" type="slidenum">
+              <a:rPr lang="en-US"/>
+              <a:t>11</a:t>
+            </a:fld>
+            <a:endParaRPr lang="en-US"/>
+          </a:p>
+        </p:txBody>
+      </p:sp>
+    </p:spTree>
+    <p:extLst>
+      <p:ext uri="{BB962C8B-B14F-4D97-AF65-F5344CB8AC3E}">
+        <p14:creationId xmlns:p14="http://schemas.microsoft.com/office/powerpoint/2010/main" val="1024086991"/>
+      </p:ext>
+    </p:extLst>
+  </p:cSld>
+  <p:clrMapOvr>
+    <a:masterClrMapping/>
+  </p:clrMapOvr>
+</p:notes>
+</file>
+
 <file path=ppt/notesSlides/notesSlide2.xml><?xml version="1.0" encoding="utf-8"?>
 <p:notes xmlns:a="http://schemas.openxmlformats.org/drawingml/2006/main" xmlns:r="http://schemas.openxmlformats.org/officeDocument/2006/relationships" xmlns:p="http://schemas.openxmlformats.org/presentationml/2006/main">
   <p:cSld>
@@ -1057,7 +1235,7 @@
           <a:p>
             <a:r>
               <a:rPr lang="en-US" dirty="0"/>
-              <a:t>These three disagreements were argued in the brief before any code. The build kept all three.</a:t>
+              <a:t>This is the real page, from a local run a week after launch, so three tasks have escalated and sit at the top. Every probability is a link to the next slide's page.</a:t>
             </a:r>
             <a:endParaRPr lang="en-US" dirty="0"/>
           </a:p>
@@ -1145,7 +1323,7 @@
           <a:p>
             <a:r>
               <a:rPr lang="en-US" dirty="0"/>
-              <a:t>Every divergence is in docs/decisions with the measurement behind it. The model choice rule was set after seeing validation numbers, and the log says so.</a:t>
+              <a:t>Traceability in one screen: the snapshot and model that made the score, the reconciliation, and a link from every factor to the raw events it was computed from.</a:t>
             </a:r>
             <a:endParaRPr lang="en-US" dirty="0"/>
           </a:p>
@@ -1233,7 +1411,7 @@
           <a:p>
             <a:r>
               <a:rPr lang="en-US" dirty="0"/>
-              <a:t>The oracle ceiling is only 0.65 because a fifth of churn has no visible signal by design. These numbers validate the pipeline and ranking on data whose generator is known; they are not evidence about real churn.</a:t>
+              <a:t>These three disagreements were argued in the brief before any code. The build kept all three.</a:t>
             </a:r>
             <a:endParaRPr lang="en-US" dirty="0"/>
           </a:p>
@@ -1321,7 +1499,7 @@
           <a:p>
             <a:r>
               <a:rPr lang="en-US" dirty="0"/>
-              <a:t>This is the agentic part as the exercise defines it: it runs without a human, decides with a policy, and leaves an audit trail. The LLM is nowhere in the ranking path.</a:t>
+              <a:t>Every divergence is in docs/decisions with the measurement behind it. The model choice rule was set after seeing validation numbers, and the log says so.</a:t>
             </a:r>
             <a:endParaRPr lang="en-US" dirty="0"/>
           </a:p>
@@ -1409,7 +1587,7 @@
           <a:p>
             <a:r>
               <a:rPr lang="en-US" dirty="0"/>
-              <a:t>All of these are linear extrapolations from the live stage timings and a local memory profile, written up in docs/decisions/step-7-10x.md.</a:t>
+              <a:t>The oracle ranks by the generator's hidden health and reaches only 0.65, because a fifth of churn has no visible signal by design. It is a reference, not a ceiling: it ignores organisation-level churn rates, so on recall@8 the models are level with it. Days to renewal alone is flat, so that row ranks by ARR. These numbers validate the pipeline and ranking on data whose generator is known; they are not evidence about real churn.</a:t>
             </a:r>
             <a:endParaRPr lang="en-US" dirty="0"/>
           </a:p>
@@ -1497,7 +1675,7 @@
           <a:p>
             <a:r>
               <a:rPr lang="en-US" dirty="0"/>
-              <a:t>The synthetic evaluation validates the mechanics. The first real-data step is to refit on actual renewals and see what the dismissal reasons say.</a:t>
+              <a:t>This is the agentic part as the exercise defines it: it runs without a human, decides with a policy, and leaves an audit trail. The LLM is nowhere in the ranking path. When a key is set, it writes a two-sentence summary after the night commits, from the reason list only, and any number it invents gets the summary rejected.</a:t>
             </a:r>
             <a:endParaRPr lang="en-US" dirty="0"/>
           </a:p>
@@ -2234,6 +2412,707 @@
 </p:sld>
 </file>
 
+<file path=ppt/slides/slide10.xml><?xml version="1.0" encoding="utf-8"?>
+<p:sld xmlns:a="http://schemas.openxmlformats.org/drawingml/2006/main" xmlns:r="http://schemas.openxmlformats.org/officeDocument/2006/relationships" xmlns:p="http://schemas.openxmlformats.org/presentationml/2006/main">
+  <p:cSld name="Slide 10">
+    <p:spTree>
+      <p:nvGrpSpPr>
+        <p:cNvPr id="1" name=""/>
+        <p:cNvGrpSpPr/>
+        <p:nvPr/>
+      </p:nvGrpSpPr>
+      <p:grpSpPr>
+        <a:xfrm>
+          <a:off x="0" y="0"/>
+          <a:ext cx="0" cy="0"/>
+          <a:chOff x="0" y="0"/>
+          <a:chExt cx="0" cy="0"/>
+        </a:xfrm>
+      </p:grpSpPr>
+      <p:sp>
+        <p:nvSpPr>
+          <p:cNvPr id="2" name="Text 0"/>
+          <p:cNvSpPr/>
+          <p:nvPr>
+            <p:ph idx="100" type="title" hasCustomPrompt="1"/>
+          </p:nvPr>
+        </p:nvSpPr>
+        <p:spPr>
+          <a:xfrm>
+            <a:off x="548640" y="320040"/>
+            <a:ext cx="11064240" cy="822960"/>
+          </a:xfrm>
+          <a:prstGeom prst="rect">
+            <a:avLst/>
+          </a:prstGeom>
+          <a:noFill/>
+          <a:ln/>
+        </p:spPr>
+        <p:txBody>
+          <a:bodyPr wrap="square" rtlCol="0" anchor="ctr"/>
+          <a:lstStyle/>
+          <a:p>
+            <a:pPr algn="l" indent="0" marL="0">
+              <a:buNone/>
+            </a:pPr>
+            <a:r>
+              <a:rPr lang="en-US" sz="3200" b="1" dirty="0">
+                <a:solidFill>
+                  <a:schemeClr val="tx1"/>
+                </a:solidFill>
+              </a:rPr>
+              <a:t>What breaks first at 10x, measured</a:t>
+            </a:r>
+            <a:endParaRPr lang="en-US" sz="3200" dirty="0"/>
+          </a:p>
+        </p:txBody>
+      </p:sp>
+      <p:sp>
+        <p:nvSpPr>
+          <p:cNvPr id="3" name="axis 10x events"/>
+          <p:cNvSpPr/>
+          <p:nvPr/>
+        </p:nvSpPr>
+        <p:spPr>
+          <a:xfrm>
+            <a:off x="548640" y="1371600"/>
+            <a:ext cx="3520440" cy="2743200"/>
+          </a:xfrm>
+          <a:prstGeom prst="roundRect">
+            <a:avLst>
+              <a:gd name="adj" fmla="val 2667"/>
+            </a:avLst>
+          </a:prstGeom>
+          <a:solidFill>
+            <a:schemeClr val="bg2"/>
+          </a:solidFill>
+          <a:ln w="12700">
+            <a:solidFill>
+              <a:schemeClr val="bg2"/>
+            </a:solidFill>
+            <a:prstDash val="solid"/>
+          </a:ln>
+        </p:spPr>
+      </p:sp>
+      <p:sp>
+        <p:nvSpPr>
+          <p:cNvPr id="4" name="Text 2"/>
+          <p:cNvSpPr txBox="1"/>
+          <p:nvPr/>
+        </p:nvSpPr>
+        <p:spPr>
+          <a:xfrm>
+            <a:off x="777240" y="1508760"/>
+            <a:ext cx="3063240" cy="457200"/>
+          </a:xfrm>
+          <a:prstGeom prst="rect">
+            <a:avLst/>
+          </a:prstGeom>
+          <a:noFill/>
+          <a:ln/>
+        </p:spPr>
+        <p:txBody>
+          <a:bodyPr wrap="square" lIns="1524" tIns="1524" rIns="1524" bIns="1524" rtlCol="0" anchor="t"/>
+          <a:lstStyle/>
+          <a:p>
+            <a:pPr indent="0" marL="0">
+              <a:buNone/>
+            </a:pPr>
+            <a:r>
+              <a:rPr lang="en-US" sz="1800" b="1" dirty="0">
+                <a:solidFill>
+                  <a:schemeClr val="accent3"/>
+                </a:solidFill>
+              </a:rPr>
+              <a:t>10x events</a:t>
+            </a:r>
+            <a:endParaRPr lang="en-US" sz="1800" dirty="0"/>
+          </a:p>
+        </p:txBody>
+      </p:sp>
+      <p:sp>
+        <p:nvSpPr>
+          <p:cNvPr id="5" name="Text 3"/>
+          <p:cNvSpPr txBox="1"/>
+          <p:nvPr/>
+        </p:nvSpPr>
+        <p:spPr>
+          <a:xfrm>
+            <a:off x="777240" y="1920240"/>
+            <a:ext cx="3063240" cy="914400"/>
+          </a:xfrm>
+          <a:prstGeom prst="rect">
+            <a:avLst/>
+          </a:prstGeom>
+          <a:noFill/>
+          <a:ln/>
+        </p:spPr>
+        <p:txBody>
+          <a:bodyPr wrap="square" lIns="1524" tIns="1524" rIns="1524" bIns="1524" rtlCol="0" anchor="ctr"/>
+          <a:lstStyle/>
+          <a:p>
+            <a:pPr indent="0" marL="0">
+              <a:buNone/>
+            </a:pPr>
+            <a:r>
+              <a:rPr lang="en-US" sz="4000" b="1" dirty="0">
+                <a:solidFill>
+                  <a:schemeClr val="tx1"/>
+                </a:solidFill>
+                <a:latin typeface="Cambria" pitchFamily="34" charset="0"/>
+                <a:ea typeface="Cambria" pitchFamily="34" charset="-122"/>
+                <a:cs typeface="Cambria" pitchFamily="34" charset="-120"/>
+              </a:rPr>
+              <a:t>~40 min</a:t>
+            </a:r>
+            <a:endParaRPr lang="en-US" sz="4000" dirty="0"/>
+          </a:p>
+        </p:txBody>
+      </p:sp>
+      <p:sp>
+        <p:nvSpPr>
+          <p:cNvPr id="6" name="Text 4"/>
+          <p:cNvSpPr txBox="1"/>
+          <p:nvPr/>
+        </p:nvSpPr>
+        <p:spPr>
+          <a:xfrm>
+            <a:off x="777240" y="2880360"/>
+            <a:ext cx="3063240" cy="1097280"/>
+          </a:xfrm>
+          <a:prstGeom prst="rect">
+            <a:avLst/>
+          </a:prstGeom>
+          <a:noFill/>
+          <a:ln/>
+        </p:spPr>
+        <p:txBody>
+          <a:bodyPr wrap="square" lIns="1524" tIns="1524" rIns="1524" bIns="1524" rtlCol="0" anchor="t"/>
+          <a:lstStyle/>
+          <a:p>
+            <a:pPr indent="0" marL="0">
+              <a:buNone/>
+            </a:pPr>
+            <a:r>
+              <a:rPr lang="en-US" sz="1400" dirty="0">
+                <a:solidFill>
+                  <a:schemeClr val="tx2"/>
+                </a:solidFill>
+              </a:rPr>
+              <a:t>for one tenant's anchor build on the VM; peaks near 0.9 GB. Breaks first, on memory.</a:t>
+            </a:r>
+            <a:endParaRPr lang="en-US" sz="1400" dirty="0"/>
+          </a:p>
+        </p:txBody>
+      </p:sp>
+      <p:sp>
+        <p:nvSpPr>
+          <p:cNvPr id="7" name="axis 10x accounts"/>
+          <p:cNvSpPr/>
+          <p:nvPr/>
+        </p:nvSpPr>
+        <p:spPr>
+          <a:xfrm>
+            <a:off x="4297680" y="1371600"/>
+            <a:ext cx="3520440" cy="2743200"/>
+          </a:xfrm>
+          <a:prstGeom prst="roundRect">
+            <a:avLst>
+              <a:gd name="adj" fmla="val 2667"/>
+            </a:avLst>
+          </a:prstGeom>
+          <a:solidFill>
+            <a:schemeClr val="bg2"/>
+          </a:solidFill>
+          <a:ln w="12700">
+            <a:solidFill>
+              <a:schemeClr val="bg2"/>
+            </a:solidFill>
+            <a:prstDash val="solid"/>
+          </a:ln>
+        </p:spPr>
+      </p:sp>
+      <p:sp>
+        <p:nvSpPr>
+          <p:cNvPr id="8" name="Text 6"/>
+          <p:cNvSpPr txBox="1"/>
+          <p:nvPr/>
+        </p:nvSpPr>
+        <p:spPr>
+          <a:xfrm>
+            <a:off x="4526280" y="1508760"/>
+            <a:ext cx="3063240" cy="457200"/>
+          </a:xfrm>
+          <a:prstGeom prst="rect">
+            <a:avLst/>
+          </a:prstGeom>
+          <a:noFill/>
+          <a:ln/>
+        </p:spPr>
+        <p:txBody>
+          <a:bodyPr wrap="square" lIns="1524" tIns="1524" rIns="1524" bIns="1524" rtlCol="0" anchor="t"/>
+          <a:lstStyle/>
+          <a:p>
+            <a:pPr indent="0" marL="0">
+              <a:buNone/>
+            </a:pPr>
+            <a:r>
+              <a:rPr lang="en-US" sz="1800" b="1" dirty="0">
+                <a:solidFill>
+                  <a:schemeClr val="accent4"/>
+                </a:solidFill>
+              </a:rPr>
+              <a:t>10x accounts</a:t>
+            </a:r>
+            <a:endParaRPr lang="en-US" sz="1800" dirty="0"/>
+          </a:p>
+        </p:txBody>
+      </p:sp>
+      <p:sp>
+        <p:nvSpPr>
+          <p:cNvPr id="9" name="Text 7"/>
+          <p:cNvSpPr txBox="1"/>
+          <p:nvPr/>
+        </p:nvSpPr>
+        <p:spPr>
+          <a:xfrm>
+            <a:off x="4526280" y="1920240"/>
+            <a:ext cx="3063240" cy="914400"/>
+          </a:xfrm>
+          <a:prstGeom prst="rect">
+            <a:avLst/>
+          </a:prstGeom>
+          <a:noFill/>
+          <a:ln/>
+        </p:spPr>
+        <p:txBody>
+          <a:bodyPr wrap="square" lIns="1524" tIns="1524" rIns="1524" bIns="1524" rtlCol="0" anchor="ctr"/>
+          <a:lstStyle/>
+          <a:p>
+            <a:pPr indent="0" marL="0">
+              <a:buNone/>
+            </a:pPr>
+            <a:r>
+              <a:rPr lang="en-US" sz="4000" b="1" dirty="0">
+                <a:solidFill>
+                  <a:schemeClr val="tx1"/>
+                </a:solidFill>
+                <a:latin typeface="Cambria" pitchFamily="34" charset="0"/>
+                <a:ea typeface="Cambria" pitchFamily="34" charset="-122"/>
+                <a:cs typeface="Cambria" pitchFamily="34" charset="-120"/>
+              </a:rPr>
+              <a:t>~4.5 GB</a:t>
+            </a:r>
+            <a:endParaRPr lang="en-US" sz="4000" dirty="0"/>
+          </a:p>
+        </p:txBody>
+      </p:sp>
+      <p:sp>
+        <p:nvSpPr>
+          <p:cNvPr id="10" name="Text 8"/>
+          <p:cNvSpPr txBox="1"/>
+          <p:nvPr/>
+        </p:nvSpPr>
+        <p:spPr>
+          <a:xfrm>
+            <a:off x="4526280" y="2880360"/>
+            <a:ext cx="3063240" cy="1097280"/>
+          </a:xfrm>
+          <a:prstGeom prst="rect">
+            <a:avLst/>
+          </a:prstGeom>
+          <a:noFill/>
+          <a:ln/>
+        </p:spPr>
+        <p:txBody>
+          <a:bodyPr wrap="square" lIns="1524" tIns="1524" rIns="1524" bIns="1524" rtlCol="0" anchor="t"/>
+          <a:lstStyle/>
+          <a:p>
+            <a:pPr indent="0" marL="0">
+              <a:buNone/>
+            </a:pPr>
+            <a:r>
+              <a:rPr lang="en-US" sz="1400" dirty="0">
+                <a:solidFill>
+                  <a:schemeClr val="tx2"/>
+                </a:solidFill>
+              </a:rPr>
+              <a:t>of snapshots, plus ~3 GB of scores a month. Disk binds within weeks.</a:t>
+            </a:r>
+            <a:endParaRPr lang="en-US" sz="1400" dirty="0"/>
+          </a:p>
+        </p:txBody>
+      </p:sp>
+      <p:sp>
+        <p:nvSpPr>
+          <p:cNvPr id="11" name="axis 10x tenants"/>
+          <p:cNvSpPr/>
+          <p:nvPr/>
+        </p:nvSpPr>
+        <p:spPr>
+          <a:xfrm>
+            <a:off x="8046720" y="1371600"/>
+            <a:ext cx="3520440" cy="2743200"/>
+          </a:xfrm>
+          <a:prstGeom prst="roundRect">
+            <a:avLst>
+              <a:gd name="adj" fmla="val 2667"/>
+            </a:avLst>
+          </a:prstGeom>
+          <a:solidFill>
+            <a:schemeClr val="bg2"/>
+          </a:solidFill>
+          <a:ln w="12700">
+            <a:solidFill>
+              <a:schemeClr val="bg2"/>
+            </a:solidFill>
+            <a:prstDash val="solid"/>
+          </a:ln>
+        </p:spPr>
+      </p:sp>
+      <p:sp>
+        <p:nvSpPr>
+          <p:cNvPr id="12" name="Text 10"/>
+          <p:cNvSpPr txBox="1"/>
+          <p:nvPr/>
+        </p:nvSpPr>
+        <p:spPr>
+          <a:xfrm>
+            <a:off x="8275320" y="1508760"/>
+            <a:ext cx="3063240" cy="457200"/>
+          </a:xfrm>
+          <a:prstGeom prst="rect">
+            <a:avLst/>
+          </a:prstGeom>
+          <a:noFill/>
+          <a:ln/>
+        </p:spPr>
+        <p:txBody>
+          <a:bodyPr wrap="square" lIns="1524" tIns="1524" rIns="1524" bIns="1524" rtlCol="0" anchor="t"/>
+          <a:lstStyle/>
+          <a:p>
+            <a:pPr indent="0" marL="0">
+              <a:buNone/>
+            </a:pPr>
+            <a:r>
+              <a:rPr lang="en-US" sz="1800" b="1" dirty="0">
+                <a:solidFill>
+                  <a:schemeClr val="accent5"/>
+                </a:solidFill>
+              </a:rPr>
+              <a:t>10x tenants</a:t>
+            </a:r>
+            <a:endParaRPr lang="en-US" sz="1800" dirty="0"/>
+          </a:p>
+        </p:txBody>
+      </p:sp>
+      <p:sp>
+        <p:nvSpPr>
+          <p:cNvPr id="13" name="Text 11"/>
+          <p:cNvSpPr txBox="1"/>
+          <p:nvPr/>
+        </p:nvSpPr>
+        <p:spPr>
+          <a:xfrm>
+            <a:off x="8275320" y="1920240"/>
+            <a:ext cx="3063240" cy="914400"/>
+          </a:xfrm>
+          <a:prstGeom prst="rect">
+            <a:avLst/>
+          </a:prstGeom>
+          <a:noFill/>
+          <a:ln/>
+        </p:spPr>
+        <p:txBody>
+          <a:bodyPr wrap="square" lIns="1524" tIns="1524" rIns="1524" bIns="1524" rtlCol="0" anchor="ctr"/>
+          <a:lstStyle/>
+          <a:p>
+            <a:pPr indent="0" marL="0">
+              <a:buNone/>
+            </a:pPr>
+            <a:r>
+              <a:rPr lang="en-US" sz="4000" b="1" dirty="0">
+                <a:solidFill>
+                  <a:schemeClr val="tx1"/>
+                </a:solidFill>
+                <a:latin typeface="Cambria" pitchFamily="34" charset="0"/>
+                <a:ea typeface="Cambria" pitchFamily="34" charset="-122"/>
+                <a:cs typeface="Cambria" pitchFamily="34" charset="-120"/>
+              </a:rPr>
+              <a:t>~3.5 min</a:t>
+            </a:r>
+            <a:endParaRPr lang="en-US" sz="4000" dirty="0"/>
+          </a:p>
+        </p:txBody>
+      </p:sp>
+      <p:sp>
+        <p:nvSpPr>
+          <p:cNvPr id="14" name="Text 12"/>
+          <p:cNvSpPr txBox="1"/>
+          <p:nvPr/>
+        </p:nvSpPr>
+        <p:spPr>
+          <a:xfrm>
+            <a:off x="8275320" y="2880360"/>
+            <a:ext cx="3063240" cy="1097280"/>
+          </a:xfrm>
+          <a:prstGeom prst="rect">
+            <a:avLst/>
+          </a:prstGeom>
+          <a:noFill/>
+          <a:ln/>
+        </p:spPr>
+        <p:txBody>
+          <a:bodyPr wrap="square" lIns="1524" tIns="1524" rIns="1524" bIns="1524" rtlCol="0" anchor="t"/>
+          <a:lstStyle/>
+          <a:p>
+            <a:pPr indent="0" marL="0">
+              <a:buNone/>
+            </a:pPr>
+            <a:r>
+              <a:rPr lang="en-US" sz="1400" dirty="0">
+                <a:solidFill>
+                  <a:schemeClr val="tx2"/>
+                </a:solidFill>
+              </a:rPr>
+              <a:t>for the nightly loop: fine. Bootstrap and training memory bind instead.</a:t>
+            </a:r>
+            <a:endParaRPr lang="en-US" sz="1400" dirty="0"/>
+          </a:p>
+        </p:txBody>
+      </p:sp>
+      <p:sp>
+        <p:nvSpPr>
+          <p:cNvPr id="15" name="Text 13"/>
+          <p:cNvSpPr txBox="1"/>
+          <p:nvPr/>
+        </p:nvSpPr>
+        <p:spPr>
+          <a:xfrm>
+            <a:off x="548640" y="4480560"/>
+            <a:ext cx="11064240" cy="1280160"/>
+          </a:xfrm>
+          <a:prstGeom prst="rect">
+            <a:avLst/>
+          </a:prstGeom>
+          <a:noFill/>
+          <a:ln/>
+        </p:spPr>
+        <p:txBody>
+          <a:bodyPr wrap="square" lIns="1524" tIns="1524" rIns="1524" bIns="1524" rtlCol="0" anchor="t"/>
+          <a:lstStyle/>
+          <a:p>
+            <a:pPr indent="0" marL="0">
+              <a:buNone/>
+            </a:pPr>
+            <a:r>
+              <a:rPr lang="en-US" sz="1600" dirty="0">
+                <a:solidFill>
+                  <a:schemeClr val="tx1"/>
+                </a:solidFill>
+              </a:rPr>
+              <a:t>Today: the whole night takes 21 s. Snapshot ~0.05 ms per event, scoring ~1 ms per account. The plan's hypothesis held, sharpened: the weekly anchor rebuild is O(weeks x events) and runs out of memory before time. Fix: incremental anchors from running aggregates, then retention and a per-tenant queue.</a:t>
+            </a:r>
+            <a:endParaRPr lang="en-US" sz="1600" dirty="0"/>
+          </a:p>
+        </p:txBody>
+      </p:sp>
+      <p:sp>
+        <p:nvSpPr>
+          <p:cNvPr id="25" name="Slide Number Placeholder 0"/>
+          <p:cNvSpPr>
+            <a:spLocks noGrp="1"/>
+          </p:cNvSpPr>
+          <p:nvPr>
+            <p:ph type="sldNum" sz="quarter" idx="4294967295"/>
+          </p:nvPr>
+        </p:nvSpPr>
+        <p:spPr>
+          <a:xfrm>
+            <a:off x="11247120" y="6400800"/>
+            <a:ext cx="548640" cy="274320"/>
+          </a:xfrm>
+          <a:prstGeom prst="rect">
+            <a:avLst/>
+          </a:prstGeom>
+          <a:extLst>
+            <a:ext uri="{C572A759-6A51-4108-AA02-DFA0A04FC94B}">
+              <ma14:wrappingTextBoxFlag xmlns:ma14="http://schemas.microsoft.com/office/mac/drawingml/2011/main" val="0"/>
+            </a:ext>
+          </a:extLst>
+        </p:spPr>
+        <p:txBody>
+          <a:bodyPr/>
+          <a:lstStyle>
+            <a:lvl1pPr>
+              <a:defRPr sz="1000">
+                <a:solidFill>
+                  <a:schemeClr val="accent6"/>
+                </a:solidFill>
+              </a:defRPr>
+            </a:lvl1pPr>
+          </a:lstStyle>
+          <a:p>
+            <a:pPr algn="r"/>
+            <a:fld id="{F7021451-1387-4CA6-816F-3879F97B5CBC}" type="slidenum">
+              <a:rPr b="0" lang="en-US"/>
+              <a:t>10</a:t>
+            </a:fld>
+            <a:endParaRPr lang="en-US"/>
+          </a:p>
+        </p:txBody>
+      </p:sp>
+    </p:spTree>
+  </p:cSld>
+  <p:clrMapOvr>
+    <a:masterClrMapping/>
+  </p:clrMapOvr>
+</p:sld>
+</file>
+
+<file path=ppt/slides/slide11.xml><?xml version="1.0" encoding="utf-8"?>
+<p:sld xmlns:a="http://schemas.openxmlformats.org/drawingml/2006/main" xmlns:r="http://schemas.openxmlformats.org/officeDocument/2006/relationships" xmlns:p="http://schemas.openxmlformats.org/presentationml/2006/main">
+  <p:cSld name="Slide 11">
+    <p:spTree>
+      <p:nvGrpSpPr>
+        <p:cNvPr id="1" name=""/>
+        <p:cNvGrpSpPr/>
+        <p:nvPr/>
+      </p:nvGrpSpPr>
+      <p:grpSpPr>
+        <a:xfrm>
+          <a:off x="0" y="0"/>
+          <a:ext cx="0" cy="0"/>
+          <a:chOff x="0" y="0"/>
+          <a:chExt cx="0" cy="0"/>
+        </a:xfrm>
+      </p:grpSpPr>
+      <p:sp>
+        <p:nvSpPr>
+          <p:cNvPr id="2" name="Text 0"/>
+          <p:cNvSpPr/>
+          <p:nvPr>
+            <p:ph idx="100" type="title" hasCustomPrompt="1"/>
+          </p:nvPr>
+        </p:nvSpPr>
+        <p:spPr>
+          <a:xfrm>
+            <a:off x="731520" y="2011680"/>
+            <a:ext cx="10698480" cy="1645920"/>
+          </a:xfrm>
+          <a:prstGeom prst="rect">
+            <a:avLst/>
+          </a:prstGeom>
+          <a:noFill/>
+          <a:ln/>
+        </p:spPr>
+        <p:txBody>
+          <a:bodyPr wrap="square" rtlCol="0" anchor="b"/>
+          <a:lstStyle/>
+          <a:p>
+            <a:pPr algn="l" indent="0" marL="0">
+              <a:buNone/>
+            </a:pPr>
+            <a:r>
+              <a:rPr lang="en-US" sz="4400" b="1" dirty="0">
+                <a:solidFill>
+                  <a:schemeClr val="bg1"/>
+                </a:solidFill>
+              </a:rPr>
+              <a:t>With real data, the first four steps</a:t>
+            </a:r>
+            <a:endParaRPr lang="en-US" sz="4400" dirty="0"/>
+          </a:p>
+        </p:txBody>
+      </p:sp>
+      <p:sp>
+        <p:nvSpPr>
+          <p:cNvPr id="3" name="Text 0"/>
+          <p:cNvSpPr/>
+          <p:nvPr>
+            <p:ph idx="101" type="body" hasCustomPrompt="1"/>
+          </p:nvPr>
+        </p:nvSpPr>
+        <p:spPr>
+          <a:xfrm>
+            <a:off x="731520" y="3794760"/>
+            <a:ext cx="10698480" cy="1463040"/>
+          </a:xfrm>
+          <a:prstGeom prst="rect">
+            <a:avLst/>
+          </a:prstGeom>
+          <a:noFill/>
+          <a:ln/>
+        </p:spPr>
+        <p:txBody>
+          <a:bodyPr wrap="square" rtlCol="0" anchor="t"/>
+          <a:lstStyle/>
+          <a:p>
+            <a:pPr algn="l" indent="0" marL="0">
+              <a:buNone/>
+            </a:pPr>
+            <a:r>
+              <a:rPr lang="en-US" sz="1800" dirty="0">
+                <a:solidFill>
+                  <a:schemeClr val="bg2"/>
+                </a:solidFill>
+              </a:rPr>
+              <a:t>1. Refit and re-baseline on real renewal outcomes; report the same holdout tables.</a:t>
+            </a:r>
+            <a:endParaRPr lang="en-US" sz="1800" dirty="0"/>
+          </a:p>
+          <a:p>
+            <a:pPr algn="l" indent="0" marL="0">
+              <a:buNone/>
+            </a:pPr>
+            <a:r>
+              <a:rPr lang="en-US" sz="1800" dirty="0">
+                <a:solidFill>
+                  <a:schemeClr val="bg2"/>
+                </a:solidFill>
+              </a:rPr>
+              <a:t>2. Use CSM dismissal reasons as labels and as a precision signal for K.</a:t>
+            </a:r>
+            <a:endParaRPr lang="en-US" sz="1800" dirty="0"/>
+          </a:p>
+          <a:p>
+            <a:pPr algn="l" indent="0" marL="0">
+              <a:buNone/>
+            </a:pPr>
+            <a:r>
+              <a:rPr lang="en-US" sz="1800" dirty="0">
+                <a:solidFill>
+                  <a:schemeClr val="bg2"/>
+                </a:solidFill>
+              </a:rPr>
+              <a:t>3. Build anchors incrementally, so history scales with events, not weeks x events.</a:t>
+            </a:r>
+            <a:endParaRPr lang="en-US" sz="1800" dirty="0"/>
+          </a:p>
+          <a:p>
+            <a:pPr algn="l" indent="0" marL="0">
+              <a:buNone/>
+            </a:pPr>
+            <a:r>
+              <a:rPr lang="en-US" sz="1800" dirty="0">
+                <a:solidFill>
+                  <a:schemeClr val="bg2"/>
+                </a:solidFill>
+              </a:rPr>
+              <a:t>4. Add identity confidence, and connectors that write the same raw-event shape.</a:t>
+            </a:r>
+            <a:endParaRPr lang="en-US" sz="1800" dirty="0"/>
+          </a:p>
+        </p:txBody>
+      </p:sp>
+    </p:spTree>
+  </p:cSld>
+  <p:clrMapOvr>
+    <a:masterClrMapping/>
+  </p:clrMapOvr>
+</p:sld>
+</file>
+
 <file path=ppt/slides/slide2.xml><?xml version="1.0" encoding="utf-8"?>
 <p:sld xmlns:a="http://schemas.openxmlformats.org/drawingml/2006/main" xmlns:r="http://schemas.openxmlformats.org/officeDocument/2006/relationships" xmlns:p="http://schemas.openxmlformats.org/presentationml/2006/main">
   <p:cSld name="Slide 2">
@@ -3560,74 +4439,46 @@
                   <a:schemeClr val="tx1"/>
                 </a:solidFill>
               </a:rPr>
-              <a:t>Where I disagreed with the request</a:t>
+              <a:t>What a CSM opens on Monday</a:t>
             </a:r>
             <a:endParaRPr lang="en-US" sz="3200" dirty="0"/>
           </a:p>
         </p:txBody>
       </p:sp>
-      <p:sp>
-        <p:nvSpPr>
-          <p:cNvPr id="3" name="card No auto-email"/>
-          <p:cNvSpPr/>
-          <p:nvPr/>
-        </p:nvSpPr>
-        <p:spPr>
-          <a:xfrm>
-            <a:off x="548640" y="1463040"/>
-            <a:ext cx="3520440" cy="3566160"/>
-          </a:xfrm>
-          <a:prstGeom prst="roundRect">
-            <a:avLst>
-              <a:gd name="adj" fmla="val 2078"/>
-            </a:avLst>
-          </a:prstGeom>
-          <a:solidFill>
-            <a:schemeClr val="bg2"/>
-          </a:solidFill>
-          <a:ln w="12700">
-            <a:solidFill>
-              <a:schemeClr val="bg2"/>
-            </a:solidFill>
-            <a:prstDash val="solid"/>
-          </a:ln>
-        </p:spPr>
-      </p:sp>
-      <p:sp>
-        <p:nvSpPr>
-          <p:cNvPr id="4" name="Shape 2"/>
-          <p:cNvSpPr/>
-          <p:nvPr/>
-        </p:nvSpPr>
-        <p:spPr>
-          <a:xfrm>
-            <a:off x="777240" y="1719072"/>
-            <a:ext cx="292608" cy="292608"/>
-          </a:xfrm>
-          <a:prstGeom prst="ellipse">
-            <a:avLst/>
-          </a:prstGeom>
-          <a:solidFill>
-            <a:schemeClr val="accent3"/>
-          </a:solidFill>
-          <a:ln w="12700">
-            <a:solidFill>
-              <a:schemeClr val="accent3"/>
-            </a:solidFill>
-            <a:prstDash val="solid"/>
-          </a:ln>
-        </p:spPr>
-      </p:sp>
-      <p:sp>
-        <p:nvSpPr>
-          <p:cNvPr id="5" name="Text 3"/>
+      <p:pic>
+        <p:nvPicPr>
+          <p:cNvPr id="3" name="screenshot list" descr="The Monday list for one CSM, with risk, ARR at risk, top reasons and tasks">    </p:cNvPr>
+          <p:cNvPicPr>
+            <a:picLocks noChangeAspect="1"/>
+          </p:cNvPicPr>
+          <p:nvPr/>
+        </p:nvPicPr>
+        <p:blipFill>
+          <a:blip r:embed="rId1"/>
+          <a:stretch>
+            <a:fillRect/>
+          </a:stretch>
+        </p:blipFill>
+        <p:spPr>
+          <a:xfrm>
+            <a:off x="548640" y="1280160"/>
+            <a:ext cx="7498080" cy="5202936"/>
+          </a:xfrm>
+          <a:prstGeom prst="rect">
+            <a:avLst/>
+          </a:prstGeom>
+        </p:spPr>
+      </p:pic>
+      <p:sp>
+        <p:nvSpPr>
+          <p:cNvPr id="4" name="Text 1"/>
           <p:cNvSpPr txBox="1"/>
           <p:nvPr/>
         </p:nvSpPr>
         <p:spPr>
           <a:xfrm>
-            <a:off x="1188720" y="1627632"/>
-            <a:ext cx="2697480" cy="457200"/>
+            <a:off x="8321040" y="1280160"/>
+            <a:ext cx="3383280" cy="5120640"/>
           </a:xfrm>
           <a:prstGeom prst="rect">
             <a:avLst/>
@@ -3636,365 +4487,119 @@
           <a:ln/>
         </p:spPr>
         <p:txBody>
-          <a:bodyPr wrap="square" lIns="1524" tIns="1524" rIns="1524" bIns="1524" rtlCol="0" anchor="ctr"/>
+          <a:bodyPr wrap="square" lIns="1524" tIns="1524" rIns="1524" bIns="1524" rtlCol="0" anchor="t"/>
           <a:lstStyle/>
           <a:p>
             <a:pPr indent="0" marL="0">
               <a:buNone/>
             </a:pPr>
             <a:r>
-              <a:rPr lang="en-US" sz="1800" b="1" dirty="0">
+              <a:rPr lang="en-US" sz="1500" b="1" dirty="0">
                 <a:solidFill>
                   <a:schemeClr val="tx1"/>
                 </a:solidFill>
               </a:rPr>
-              <a:t>No auto-email</a:t>
-            </a:r>
-            <a:endParaRPr lang="en-US" sz="1800" dirty="0"/>
-          </a:p>
-        </p:txBody>
-      </p:sp>
-      <p:sp>
-        <p:nvSpPr>
-          <p:cNvPr id="6" name="Text 4"/>
-          <p:cNvSpPr txBox="1"/>
-          <p:nvPr/>
-        </p:nvSpPr>
-        <p:spPr>
-          <a:xfrm>
-            <a:off x="777240" y="2176272"/>
-            <a:ext cx="3063240" cy="2697480"/>
-          </a:xfrm>
-          <a:prstGeom prst="rect">
-            <a:avLst/>
-          </a:prstGeom>
-          <a:noFill/>
-          <a:ln/>
-        </p:spPr>
-        <p:txBody>
-          <a:bodyPr wrap="square" lIns="1524" tIns="1524" rIns="1524" bIns="1524" rtlCol="0" anchor="t"/>
-          <a:lstStyle/>
+              <a:t>Ranked by ARR at risk</a:t>
+            </a:r>
+            <a:endParaRPr lang="en-US" sz="1500" dirty="0"/>
+          </a:p>
           <a:p>
             <a:pPr indent="0" marL="0">
               <a:buNone/>
             </a:pPr>
             <a:r>
-              <a:rPr lang="en-US" sz="1400" dirty="0">
-                <a:solidFill>
-                  <a:schemeClr val="tx2"/>
-                </a:solidFill>
-              </a:rPr>
-              <a:t>Wrong recipient: the champion may have left. Wrong message: a backlog and a failed payment need different calls. Wrong trigger: scores near a line flip weekly.</a:t>
-            </a:r>
-            <a:endParaRPr lang="en-US" sz="1400" dirty="0"/>
+              <a:rPr lang="en-US" sz="1500" dirty="0">
+                <a:solidFill>
+                  <a:schemeClr val="tx1"/>
+                </a:solidFill>
+              </a:rPr>
+              <a:t>Probability × ARR. One click re-sorts by probability, ARR or renewal date.</a:t>
+            </a:r>
+            <a:endParaRPr lang="en-US" sz="1500" dirty="0"/>
           </a:p>
           <a:p>
             <a:pPr indent="0" marL="0">
               <a:buNone/>
             </a:pPr>
-            <a:endParaRPr lang="en-US" sz="1400" dirty="0"/>
+            <a:r>
+              <a:rPr lang="en-US" sz="1500" dirty="0">
+                <a:solidFill>
+                  <a:schemeClr val="tx1"/>
+                </a:solidFill>
+              </a:rPr>
+              <a:t> </a:t>
+            </a:r>
+            <a:endParaRPr lang="en-US" sz="1500" dirty="0"/>
           </a:p>
           <a:p>
             <a:pPr indent="0" marL="0">
               <a:buNone/>
             </a:pPr>
             <a:r>
-              <a:rPr lang="en-US" sz="1400" dirty="0">
-                <a:solidFill>
-                  <a:schemeClr val="tx2"/>
-                </a:solidFill>
-              </a:rPr>
-              <a:t>Instead: a task, escalated after 5 business days near renewal. Nothing goes unseen.</a:t>
-            </a:r>
-            <a:endParaRPr lang="en-US" sz="1400" dirty="0"/>
-          </a:p>
-        </p:txBody>
-      </p:sp>
-      <p:sp>
-        <p:nvSpPr>
-          <p:cNvPr id="7" name="card Colour from rank"/>
-          <p:cNvSpPr/>
-          <p:nvPr/>
-        </p:nvSpPr>
-        <p:spPr>
-          <a:xfrm>
-            <a:off x="4297680" y="1463040"/>
-            <a:ext cx="3520440" cy="3566160"/>
-          </a:xfrm>
-          <a:prstGeom prst="roundRect">
-            <a:avLst>
-              <a:gd name="adj" fmla="val 2078"/>
-            </a:avLst>
-          </a:prstGeom>
-          <a:solidFill>
-            <a:schemeClr val="bg2"/>
-          </a:solidFill>
-          <a:ln w="12700">
-            <a:solidFill>
-              <a:schemeClr val="bg2"/>
-            </a:solidFill>
-            <a:prstDash val="solid"/>
-          </a:ln>
-        </p:spPr>
-      </p:sp>
-      <p:sp>
-        <p:nvSpPr>
-          <p:cNvPr id="8" name="Shape 6"/>
-          <p:cNvSpPr/>
-          <p:nvPr/>
-        </p:nvSpPr>
-        <p:spPr>
-          <a:xfrm>
-            <a:off x="4526280" y="1719072"/>
-            <a:ext cx="292608" cy="292608"/>
-          </a:xfrm>
-          <a:prstGeom prst="ellipse">
-            <a:avLst/>
-          </a:prstGeom>
-          <a:solidFill>
-            <a:schemeClr val="accent4"/>
-          </a:solidFill>
-          <a:ln w="12700">
-            <a:solidFill>
-              <a:schemeClr val="accent4"/>
-            </a:solidFill>
-            <a:prstDash val="solid"/>
-          </a:ln>
-        </p:spPr>
-      </p:sp>
-      <p:sp>
-        <p:nvSpPr>
-          <p:cNvPr id="9" name="Text 7"/>
-          <p:cNvSpPr txBox="1"/>
-          <p:nvPr/>
-        </p:nvSpPr>
-        <p:spPr>
-          <a:xfrm>
-            <a:off x="4937760" y="1627632"/>
-            <a:ext cx="2697480" cy="457200"/>
-          </a:xfrm>
-          <a:prstGeom prst="rect">
-            <a:avLst/>
-          </a:prstGeom>
-          <a:noFill/>
-          <a:ln/>
-        </p:spPr>
-        <p:txBody>
-          <a:bodyPr wrap="square" lIns="1524" tIns="1524" rIns="1524" bIns="1524" rtlCol="0" anchor="ctr"/>
-          <a:lstStyle/>
+              <a:rPr lang="en-US" sz="1500" b="1" dirty="0">
+                <a:solidFill>
+                  <a:schemeClr val="tx1"/>
+                </a:solidFill>
+              </a:rPr>
+              <a:t>Reasons on the row</a:t>
+            </a:r>
+            <a:endParaRPr lang="en-US" sz="1500" dirty="0"/>
+          </a:p>
           <a:p>
             <a:pPr indent="0" marL="0">
               <a:buNone/>
             </a:pPr>
             <a:r>
-              <a:rPr lang="en-US" sz="1800" b="1" dirty="0">
+              <a:rPr lang="en-US" sz="1500" dirty="0">
                 <a:solidFill>
                   <a:schemeClr val="tx1"/>
                 </a:solidFill>
               </a:rPr>
-              <a:t>Colour from rank</a:t>
-            </a:r>
-            <a:endParaRPr lang="en-US" sz="1800" dirty="0"/>
-          </a:p>
-        </p:txBody>
-      </p:sp>
-      <p:sp>
-        <p:nvSpPr>
-          <p:cNvPr id="10" name="Text 8"/>
-          <p:cNvSpPr txBox="1"/>
-          <p:nvPr/>
-        </p:nvSpPr>
-        <p:spPr>
-          <a:xfrm>
-            <a:off x="4526280" y="2176272"/>
-            <a:ext cx="3063240" cy="2697480"/>
-          </a:xfrm>
-          <a:prstGeom prst="rect">
-            <a:avLst/>
-          </a:prstGeom>
-          <a:noFill/>
-          <a:ln/>
-        </p:spPr>
-        <p:txBody>
-          <a:bodyPr wrap="square" lIns="1524" tIns="1524" rIns="1524" bIns="1524" rtlCol="0" anchor="t"/>
-          <a:lstStyle/>
+              <a:t>The model's own top factors, with their values. Small pushes stay on the score page.</a:t>
+            </a:r>
+            <a:endParaRPr lang="en-US" sz="1500" dirty="0"/>
+          </a:p>
           <a:p>
             <a:pPr indent="0" marL="0">
               <a:buNone/>
             </a:pPr>
             <a:r>
-              <a:rPr lang="en-US" sz="1400" dirty="0">
-                <a:solidFill>
-                  <a:schemeClr val="tx2"/>
-                </a:solidFill>
-              </a:rPr>
-              <a:t>Red is the top 8 of the CSM's book, yellow the next 16. Every CSM always has a week of red.</a:t>
-            </a:r>
-            <a:endParaRPr lang="en-US" sz="1400" dirty="0"/>
+              <a:rPr lang="en-US" sz="1500" dirty="0">
+                <a:solidFill>
+                  <a:schemeClr val="tx1"/>
+                </a:solidFill>
+              </a:rPr>
+              <a:t> </a:t>
+            </a:r>
+            <a:endParaRPr lang="en-US" sz="1500" dirty="0"/>
           </a:p>
           <a:p>
             <a:pPr indent="0" marL="0">
               <a:buNone/>
             </a:pPr>
-            <a:endParaRPr lang="en-US" sz="1400" dirty="0"/>
+            <a:r>
+              <a:rPr lang="en-US" sz="1500" b="1" dirty="0">
+                <a:solidFill>
+                  <a:schemeClr val="tx1"/>
+                </a:solidFill>
+              </a:rPr>
+              <a:t>Tasks that cannot slip</a:t>
+            </a:r>
+            <a:endParaRPr lang="en-US" sz="1500" dirty="0"/>
           </a:p>
           <a:p>
             <a:pPr indent="0" marL="0">
               <a:buNone/>
             </a:pPr>
             <a:r>
-              <a:rPr lang="en-US" sz="1400" dirty="0">
-                <a:solidFill>
-                  <a:schemeClr val="tx2"/>
-                </a:solidFill>
-              </a:rPr>
-              <a:t>Fixed probability bands drift with every retrain. Probability and ARR stay visible as columns.</a:t>
-            </a:r>
-            <a:endParaRPr lang="en-US" sz="1400" dirty="0"/>
-          </a:p>
-        </p:txBody>
-      </p:sp>
-      <p:sp>
-        <p:nvSpPr>
-          <p:cNvPr id="11" name="card Rank by ARR at risk"/>
-          <p:cNvSpPr/>
-          <p:nvPr/>
-        </p:nvSpPr>
-        <p:spPr>
-          <a:xfrm>
-            <a:off x="8046720" y="1463040"/>
-            <a:ext cx="3520440" cy="3566160"/>
-          </a:xfrm>
-          <a:prstGeom prst="roundRect">
-            <a:avLst>
-              <a:gd name="adj" fmla="val 2078"/>
-            </a:avLst>
-          </a:prstGeom>
-          <a:solidFill>
-            <a:schemeClr val="bg2"/>
-          </a:solidFill>
-          <a:ln w="12700">
-            <a:solidFill>
-              <a:schemeClr val="bg2"/>
-            </a:solidFill>
-            <a:prstDash val="solid"/>
-          </a:ln>
-        </p:spPr>
-      </p:sp>
-      <p:sp>
-        <p:nvSpPr>
-          <p:cNvPr id="12" name="Shape 10"/>
-          <p:cNvSpPr/>
-          <p:nvPr/>
-        </p:nvSpPr>
-        <p:spPr>
-          <a:xfrm>
-            <a:off x="8275320" y="1719072"/>
-            <a:ext cx="292608" cy="292608"/>
-          </a:xfrm>
-          <a:prstGeom prst="ellipse">
-            <a:avLst/>
-          </a:prstGeom>
-          <a:solidFill>
-            <a:schemeClr val="accent5"/>
-          </a:solidFill>
-          <a:ln w="12700">
-            <a:solidFill>
-              <a:schemeClr val="accent5"/>
-            </a:solidFill>
-            <a:prstDash val="solid"/>
-          </a:ln>
-        </p:spPr>
-      </p:sp>
-      <p:sp>
-        <p:nvSpPr>
-          <p:cNvPr id="13" name="Text 11"/>
-          <p:cNvSpPr txBox="1"/>
-          <p:nvPr/>
-        </p:nvSpPr>
-        <p:spPr>
-          <a:xfrm>
-            <a:off x="8686800" y="1627632"/>
-            <a:ext cx="2697480" cy="457200"/>
-          </a:xfrm>
-          <a:prstGeom prst="rect">
-            <a:avLst/>
-          </a:prstGeom>
-          <a:noFill/>
-          <a:ln/>
-        </p:spPr>
-        <p:txBody>
-          <a:bodyPr wrap="square" lIns="1524" tIns="1524" rIns="1524" bIns="1524" rtlCol="0" anchor="ctr"/>
-          <a:lstStyle/>
-          <a:p>
-            <a:pPr indent="0" marL="0">
-              <a:buNone/>
-            </a:pPr>
-            <a:r>
-              <a:rPr lang="en-US" sz="1800" b="1" dirty="0">
+              <a:rPr lang="en-US" sz="1500" dirty="0">
                 <a:solidFill>
                   <a:schemeClr val="tx1"/>
                 </a:solidFill>
               </a:rPr>
-              <a:t>Rank by ARR at risk</a:t>
-            </a:r>
-            <a:endParaRPr lang="en-US" sz="1800" dirty="0"/>
-          </a:p>
-        </p:txBody>
-      </p:sp>
-      <p:sp>
-        <p:nvSpPr>
-          <p:cNvPr id="14" name="Text 12"/>
-          <p:cNvSpPr txBox="1"/>
-          <p:nvPr/>
-        </p:nvSpPr>
-        <p:spPr>
-          <a:xfrm>
-            <a:off x="8275320" y="2176272"/>
-            <a:ext cx="3063240" cy="2697480"/>
-          </a:xfrm>
-          <a:prstGeom prst="rect">
-            <a:avLst/>
-          </a:prstGeom>
-          <a:noFill/>
-          <a:ln/>
-        </p:spPr>
-        <p:txBody>
-          <a:bodyPr wrap="square" lIns="1524" tIns="1524" rIns="1524" bIns="1524" rtlCol="0" anchor="t"/>
-          <a:lstStyle/>
-          <a:p>
-            <a:pPr indent="0" marL="0">
-              <a:buNone/>
-            </a:pPr>
-            <a:r>
-              <a:rPr lang="en-US" sz="1400" dirty="0">
-                <a:solidFill>
-                  <a:schemeClr val="tx2"/>
-                </a:solidFill>
-              </a:rPr>
-              <a:t>A $2k account at 60% should not outrank a $200k account at 50%. Rank score is probability x ARR, with one-click re-sort.</a:t>
-            </a:r>
-            <a:endParaRPr lang="en-US" sz="1400" dirty="0"/>
-          </a:p>
-          <a:p>
-            <a:pPr indent="0" marL="0">
-              <a:buNone/>
-            </a:pPr>
-            <a:endParaRPr lang="en-US" sz="1400" dirty="0"/>
-          </a:p>
-          <a:p>
-            <a:pPr indent="0" marL="0">
-              <a:buNone/>
-            </a:pPr>
-            <a:r>
-              <a:rPr lang="en-US" sz="1400" dirty="0">
-                <a:solidFill>
-                  <a:schemeClr val="tx2"/>
-                </a:solidFill>
-              </a:rPr>
-              <a:t>Label: the next renewal's outcome, so accounts far from renewal still get early warning.</a:t>
-            </a:r>
-            <a:endParaRPr lang="en-US" sz="1400" dirty="0"/>
+              <a:t>Untouched for 5 business days near renewal: escalated and pinned first.</a:t>
+            </a:r>
+            <a:endParaRPr lang="en-US" sz="1500" dirty="0"/>
           </a:p>
         </p:txBody>
       </p:sp>
@@ -4100,6 +4705,812 @@
                   <a:schemeClr val="tx1"/>
                 </a:solidFill>
               </a:rPr>
+              <a:t>Every number traces back to raw events</a:t>
+            </a:r>
+            <a:endParaRPr lang="en-US" sz="3200" dirty="0"/>
+          </a:p>
+        </p:txBody>
+      </p:sp>
+      <p:pic>
+        <p:nvPicPr>
+          <p:cNvPr id="3" name="screenshot score" descr="The score drill-down, with each factor's contribution and the reconciliation check">    </p:cNvPr>
+          <p:cNvPicPr>
+            <a:picLocks noChangeAspect="1"/>
+          </p:cNvPicPr>
+          <p:nvPr/>
+        </p:nvPicPr>
+        <p:blipFill>
+          <a:blip r:embed="rId1"/>
+          <a:stretch>
+            <a:fillRect/>
+          </a:stretch>
+        </p:blipFill>
+        <p:spPr>
+          <a:xfrm>
+            <a:off x="548640" y="1280160"/>
+            <a:ext cx="6400800" cy="5111496"/>
+          </a:xfrm>
+          <a:prstGeom prst="rect">
+            <a:avLst/>
+          </a:prstGeom>
+        </p:spPr>
+      </p:pic>
+      <p:sp>
+        <p:nvSpPr>
+          <p:cNvPr id="4" name="Text 1"/>
+          <p:cNvSpPr txBox="1"/>
+          <p:nvPr/>
+        </p:nvSpPr>
+        <p:spPr>
+          <a:xfrm>
+            <a:off x="7315200" y="1280160"/>
+            <a:ext cx="4389120" cy="5120640"/>
+          </a:xfrm>
+          <a:prstGeom prst="rect">
+            <a:avLst/>
+          </a:prstGeom>
+          <a:noFill/>
+          <a:ln/>
+        </p:spPr>
+        <p:txBody>
+          <a:bodyPr wrap="square" lIns="1524" tIns="1524" rIns="1524" bIns="1524" rtlCol="0" anchor="t"/>
+          <a:lstStyle/>
+          <a:p>
+            <a:pPr indent="0" marL="0">
+              <a:buNone/>
+            </a:pPr>
+            <a:r>
+              <a:rPr lang="en-US" sz="1500" b="1" dirty="0">
+                <a:solidFill>
+                  <a:schemeClr val="tx1"/>
+                </a:solidFill>
+              </a:rPr>
+              <a:t>Factor by factor</a:t>
+            </a:r>
+            <a:endParaRPr lang="en-US" sz="1500" dirty="0"/>
+          </a:p>
+          <a:p>
+            <a:pPr indent="0" marL="0">
+              <a:buNone/>
+            </a:pPr>
+            <a:r>
+              <a:rPr lang="en-US" sz="1500" dirty="0">
+                <a:solidFill>
+                  <a:schemeClr val="tx1"/>
+                </a:solidFill>
+              </a:rPr>
+              <a:t>Each contribution, largest first, from the same model that scored.</a:t>
+            </a:r>
+            <a:endParaRPr lang="en-US" sz="1500" dirty="0"/>
+          </a:p>
+          <a:p>
+            <a:pPr indent="0" marL="0">
+              <a:buNone/>
+            </a:pPr>
+            <a:r>
+              <a:rPr lang="en-US" sz="1500" dirty="0">
+                <a:solidFill>
+                  <a:schemeClr val="tx1"/>
+                </a:solidFill>
+              </a:rPr>
+              <a:t> </a:t>
+            </a:r>
+            <a:endParaRPr lang="en-US" sz="1500" dirty="0"/>
+          </a:p>
+          <a:p>
+            <a:pPr indent="0" marL="0">
+              <a:buNone/>
+            </a:pPr>
+            <a:r>
+              <a:rPr lang="en-US" sz="1500" b="1" dirty="0">
+                <a:solidFill>
+                  <a:schemeClr val="tx1"/>
+                </a:solidFill>
+              </a:rPr>
+              <a:t>Checked on the page</a:t>
+            </a:r>
+            <a:endParaRPr lang="en-US" sz="1500" dirty="0"/>
+          </a:p>
+          <a:p>
+            <a:pPr indent="0" marL="0">
+              <a:buNone/>
+            </a:pPr>
+            <a:r>
+              <a:rPr lang="en-US" sz="1500" dirty="0">
+                <a:solidFill>
+                  <a:schemeClr val="tx1"/>
+                </a:solidFill>
+              </a:rPr>
+              <a:t>Expected value + contributions = the stored margin. rescore &lt;score_id&gt; reproduces it.</a:t>
+            </a:r>
+            <a:endParaRPr lang="en-US" sz="1500" dirty="0"/>
+          </a:p>
+          <a:p>
+            <a:pPr indent="0" marL="0">
+              <a:buNone/>
+            </a:pPr>
+            <a:r>
+              <a:rPr lang="en-US" sz="1500" dirty="0">
+                <a:solidFill>
+                  <a:schemeClr val="tx1"/>
+                </a:solidFill>
+              </a:rPr>
+              <a:t> </a:t>
+            </a:r>
+            <a:endParaRPr lang="en-US" sz="1500" dirty="0"/>
+          </a:p>
+          <a:p>
+            <a:pPr indent="0" marL="0">
+              <a:buNone/>
+            </a:pPr>
+            <a:r>
+              <a:rPr lang="en-US" sz="1500" b="1" dirty="0">
+                <a:solidFill>
+                  <a:schemeClr val="tx1"/>
+                </a:solidFill>
+              </a:rPr>
+              <a:t>Down to the events</a:t>
+            </a:r>
+            <a:endParaRPr lang="en-US" sz="1500" dirty="0"/>
+          </a:p>
+          <a:p>
+            <a:pPr indent="0" marL="0">
+              <a:buNone/>
+            </a:pPr>
+            <a:r>
+              <a:rPr lang="en-US" sz="1500" dirty="0">
+                <a:solidFill>
+                  <a:schemeClr val="tx1"/>
+                </a:solidFill>
+              </a:rPr>
+              <a:t>"raw events" shows the exact rows a factor counted, received before the snapshot.</a:t>
+            </a:r>
+            <a:endParaRPr lang="en-US" sz="1500" dirty="0"/>
+          </a:p>
+        </p:txBody>
+      </p:sp>
+      <p:sp>
+        <p:nvSpPr>
+          <p:cNvPr id="25" name="Slide Number Placeholder 0"/>
+          <p:cNvSpPr>
+            <a:spLocks noGrp="1"/>
+          </p:cNvSpPr>
+          <p:nvPr>
+            <p:ph type="sldNum" sz="quarter" idx="4294967295"/>
+          </p:nvPr>
+        </p:nvSpPr>
+        <p:spPr>
+          <a:xfrm>
+            <a:off x="11247120" y="6400800"/>
+            <a:ext cx="548640" cy="274320"/>
+          </a:xfrm>
+          <a:prstGeom prst="rect">
+            <a:avLst/>
+          </a:prstGeom>
+          <a:extLst>
+            <a:ext uri="{C572A759-6A51-4108-AA02-DFA0A04FC94B}">
+              <ma14:wrappingTextBoxFlag xmlns:ma14="http://schemas.microsoft.com/office/mac/drawingml/2011/main" val="0"/>
+            </a:ext>
+          </a:extLst>
+        </p:spPr>
+        <p:txBody>
+          <a:bodyPr/>
+          <a:lstStyle>
+            <a:lvl1pPr>
+              <a:defRPr sz="1000">
+                <a:solidFill>
+                  <a:schemeClr val="accent6"/>
+                </a:solidFill>
+              </a:defRPr>
+            </a:lvl1pPr>
+          </a:lstStyle>
+          <a:p>
+            <a:pPr algn="r"/>
+            <a:fld id="{F7021451-1387-4CA6-816F-3879F97B5CBC}" type="slidenum">
+              <a:rPr b="0" lang="en-US"/>
+              <a:t>5</a:t>
+            </a:fld>
+            <a:endParaRPr lang="en-US"/>
+          </a:p>
+        </p:txBody>
+      </p:sp>
+    </p:spTree>
+  </p:cSld>
+  <p:clrMapOvr>
+    <a:masterClrMapping/>
+  </p:clrMapOvr>
+</p:sld>
+</file>
+
+<file path=ppt/slides/slide6.xml><?xml version="1.0" encoding="utf-8"?>
+<p:sld xmlns:a="http://schemas.openxmlformats.org/drawingml/2006/main" xmlns:r="http://schemas.openxmlformats.org/officeDocument/2006/relationships" xmlns:p="http://schemas.openxmlformats.org/presentationml/2006/main">
+  <p:cSld name="Slide 6">
+    <p:spTree>
+      <p:nvGrpSpPr>
+        <p:cNvPr id="1" name=""/>
+        <p:cNvGrpSpPr/>
+        <p:nvPr/>
+      </p:nvGrpSpPr>
+      <p:grpSpPr>
+        <a:xfrm>
+          <a:off x="0" y="0"/>
+          <a:ext cx="0" cy="0"/>
+          <a:chOff x="0" y="0"/>
+          <a:chExt cx="0" cy="0"/>
+        </a:xfrm>
+      </p:grpSpPr>
+      <p:sp>
+        <p:nvSpPr>
+          <p:cNvPr id="2" name="Text 0"/>
+          <p:cNvSpPr/>
+          <p:nvPr>
+            <p:ph idx="100" type="title" hasCustomPrompt="1"/>
+          </p:nvPr>
+        </p:nvSpPr>
+        <p:spPr>
+          <a:xfrm>
+            <a:off x="548640" y="320040"/>
+            <a:ext cx="11064240" cy="822960"/>
+          </a:xfrm>
+          <a:prstGeom prst="rect">
+            <a:avLst/>
+          </a:prstGeom>
+          <a:noFill/>
+          <a:ln/>
+        </p:spPr>
+        <p:txBody>
+          <a:bodyPr wrap="square" rtlCol="0" anchor="ctr"/>
+          <a:lstStyle/>
+          <a:p>
+            <a:pPr algn="l" indent="0" marL="0">
+              <a:buNone/>
+            </a:pPr>
+            <a:r>
+              <a:rPr lang="en-US" sz="3200" b="1" dirty="0">
+                <a:solidFill>
+                  <a:schemeClr val="tx1"/>
+                </a:solidFill>
+              </a:rPr>
+              <a:t>Where I disagreed with the request</a:t>
+            </a:r>
+            <a:endParaRPr lang="en-US" sz="3200" dirty="0"/>
+          </a:p>
+        </p:txBody>
+      </p:sp>
+      <p:sp>
+        <p:nvSpPr>
+          <p:cNvPr id="3" name="card No auto-email"/>
+          <p:cNvSpPr/>
+          <p:nvPr/>
+        </p:nvSpPr>
+        <p:spPr>
+          <a:xfrm>
+            <a:off x="548640" y="1463040"/>
+            <a:ext cx="3520440" cy="3566160"/>
+          </a:xfrm>
+          <a:prstGeom prst="roundRect">
+            <a:avLst>
+              <a:gd name="adj" fmla="val 2078"/>
+            </a:avLst>
+          </a:prstGeom>
+          <a:solidFill>
+            <a:schemeClr val="bg2"/>
+          </a:solidFill>
+          <a:ln w="12700">
+            <a:solidFill>
+              <a:schemeClr val="bg2"/>
+            </a:solidFill>
+            <a:prstDash val="solid"/>
+          </a:ln>
+        </p:spPr>
+      </p:sp>
+      <p:sp>
+        <p:nvSpPr>
+          <p:cNvPr id="4" name="Shape 2"/>
+          <p:cNvSpPr/>
+          <p:nvPr/>
+        </p:nvSpPr>
+        <p:spPr>
+          <a:xfrm>
+            <a:off x="777240" y="1719072"/>
+            <a:ext cx="292608" cy="292608"/>
+          </a:xfrm>
+          <a:prstGeom prst="ellipse">
+            <a:avLst/>
+          </a:prstGeom>
+          <a:solidFill>
+            <a:schemeClr val="accent3"/>
+          </a:solidFill>
+          <a:ln w="12700">
+            <a:solidFill>
+              <a:schemeClr val="accent3"/>
+            </a:solidFill>
+            <a:prstDash val="solid"/>
+          </a:ln>
+        </p:spPr>
+      </p:sp>
+      <p:sp>
+        <p:nvSpPr>
+          <p:cNvPr id="5" name="Text 3"/>
+          <p:cNvSpPr txBox="1"/>
+          <p:nvPr/>
+        </p:nvSpPr>
+        <p:spPr>
+          <a:xfrm>
+            <a:off x="1188720" y="1627632"/>
+            <a:ext cx="2697480" cy="457200"/>
+          </a:xfrm>
+          <a:prstGeom prst="rect">
+            <a:avLst/>
+          </a:prstGeom>
+          <a:noFill/>
+          <a:ln/>
+        </p:spPr>
+        <p:txBody>
+          <a:bodyPr wrap="square" lIns="1524" tIns="1524" rIns="1524" bIns="1524" rtlCol="0" anchor="ctr"/>
+          <a:lstStyle/>
+          <a:p>
+            <a:pPr indent="0" marL="0">
+              <a:buNone/>
+            </a:pPr>
+            <a:r>
+              <a:rPr lang="en-US" sz="1800" b="1" dirty="0">
+                <a:solidFill>
+                  <a:schemeClr val="tx1"/>
+                </a:solidFill>
+              </a:rPr>
+              <a:t>No auto-email</a:t>
+            </a:r>
+            <a:endParaRPr lang="en-US" sz="1800" dirty="0"/>
+          </a:p>
+        </p:txBody>
+      </p:sp>
+      <p:sp>
+        <p:nvSpPr>
+          <p:cNvPr id="6" name="Text 4"/>
+          <p:cNvSpPr txBox="1"/>
+          <p:nvPr/>
+        </p:nvSpPr>
+        <p:spPr>
+          <a:xfrm>
+            <a:off x="777240" y="2176272"/>
+            <a:ext cx="3063240" cy="2697480"/>
+          </a:xfrm>
+          <a:prstGeom prst="rect">
+            <a:avLst/>
+          </a:prstGeom>
+          <a:noFill/>
+          <a:ln/>
+        </p:spPr>
+        <p:txBody>
+          <a:bodyPr wrap="square" lIns="1524" tIns="1524" rIns="1524" bIns="1524" rtlCol="0" anchor="t"/>
+          <a:lstStyle/>
+          <a:p>
+            <a:pPr indent="0" marL="0">
+              <a:buNone/>
+            </a:pPr>
+            <a:r>
+              <a:rPr lang="en-US" sz="1400" dirty="0">
+                <a:solidFill>
+                  <a:schemeClr val="tx2"/>
+                </a:solidFill>
+              </a:rPr>
+              <a:t>Wrong recipient: the champion may have left. Wrong message: a backlog and a failed payment need different calls. Wrong trigger: scores near a line flip weekly.</a:t>
+            </a:r>
+            <a:endParaRPr lang="en-US" sz="1400" dirty="0"/>
+          </a:p>
+          <a:p>
+            <a:pPr indent="0" marL="0">
+              <a:buNone/>
+            </a:pPr>
+            <a:endParaRPr lang="en-US" sz="1400" dirty="0"/>
+          </a:p>
+          <a:p>
+            <a:pPr indent="0" marL="0">
+              <a:buNone/>
+            </a:pPr>
+            <a:r>
+              <a:rPr lang="en-US" sz="1400" dirty="0">
+                <a:solidFill>
+                  <a:schemeClr val="tx2"/>
+                </a:solidFill>
+              </a:rPr>
+              <a:t>Instead: a task, escalated after 5 business days near renewal. Nothing goes unseen.</a:t>
+            </a:r>
+            <a:endParaRPr lang="en-US" sz="1400" dirty="0"/>
+          </a:p>
+        </p:txBody>
+      </p:sp>
+      <p:sp>
+        <p:nvSpPr>
+          <p:cNvPr id="7" name="card Colour from rank"/>
+          <p:cNvSpPr/>
+          <p:nvPr/>
+        </p:nvSpPr>
+        <p:spPr>
+          <a:xfrm>
+            <a:off x="4297680" y="1463040"/>
+            <a:ext cx="3520440" cy="3566160"/>
+          </a:xfrm>
+          <a:prstGeom prst="roundRect">
+            <a:avLst>
+              <a:gd name="adj" fmla="val 2078"/>
+            </a:avLst>
+          </a:prstGeom>
+          <a:solidFill>
+            <a:schemeClr val="bg2"/>
+          </a:solidFill>
+          <a:ln w="12700">
+            <a:solidFill>
+              <a:schemeClr val="bg2"/>
+            </a:solidFill>
+            <a:prstDash val="solid"/>
+          </a:ln>
+        </p:spPr>
+      </p:sp>
+      <p:sp>
+        <p:nvSpPr>
+          <p:cNvPr id="8" name="Shape 6"/>
+          <p:cNvSpPr/>
+          <p:nvPr/>
+        </p:nvSpPr>
+        <p:spPr>
+          <a:xfrm>
+            <a:off x="4526280" y="1719072"/>
+            <a:ext cx="292608" cy="292608"/>
+          </a:xfrm>
+          <a:prstGeom prst="ellipse">
+            <a:avLst/>
+          </a:prstGeom>
+          <a:solidFill>
+            <a:schemeClr val="accent4"/>
+          </a:solidFill>
+          <a:ln w="12700">
+            <a:solidFill>
+              <a:schemeClr val="accent4"/>
+            </a:solidFill>
+            <a:prstDash val="solid"/>
+          </a:ln>
+        </p:spPr>
+      </p:sp>
+      <p:sp>
+        <p:nvSpPr>
+          <p:cNvPr id="9" name="Text 7"/>
+          <p:cNvSpPr txBox="1"/>
+          <p:nvPr/>
+        </p:nvSpPr>
+        <p:spPr>
+          <a:xfrm>
+            <a:off x="4937760" y="1627632"/>
+            <a:ext cx="2697480" cy="457200"/>
+          </a:xfrm>
+          <a:prstGeom prst="rect">
+            <a:avLst/>
+          </a:prstGeom>
+          <a:noFill/>
+          <a:ln/>
+        </p:spPr>
+        <p:txBody>
+          <a:bodyPr wrap="square" lIns="1524" tIns="1524" rIns="1524" bIns="1524" rtlCol="0" anchor="ctr"/>
+          <a:lstStyle/>
+          <a:p>
+            <a:pPr indent="0" marL="0">
+              <a:buNone/>
+            </a:pPr>
+            <a:r>
+              <a:rPr lang="en-US" sz="1800" b="1" dirty="0">
+                <a:solidFill>
+                  <a:schemeClr val="tx1"/>
+                </a:solidFill>
+              </a:rPr>
+              <a:t>Colour from rank</a:t>
+            </a:r>
+            <a:endParaRPr lang="en-US" sz="1800" dirty="0"/>
+          </a:p>
+        </p:txBody>
+      </p:sp>
+      <p:sp>
+        <p:nvSpPr>
+          <p:cNvPr id="10" name="Text 8"/>
+          <p:cNvSpPr txBox="1"/>
+          <p:nvPr/>
+        </p:nvSpPr>
+        <p:spPr>
+          <a:xfrm>
+            <a:off x="4526280" y="2176272"/>
+            <a:ext cx="3063240" cy="2697480"/>
+          </a:xfrm>
+          <a:prstGeom prst="rect">
+            <a:avLst/>
+          </a:prstGeom>
+          <a:noFill/>
+          <a:ln/>
+        </p:spPr>
+        <p:txBody>
+          <a:bodyPr wrap="square" lIns="1524" tIns="1524" rIns="1524" bIns="1524" rtlCol="0" anchor="t"/>
+          <a:lstStyle/>
+          <a:p>
+            <a:pPr indent="0" marL="0">
+              <a:buNone/>
+            </a:pPr>
+            <a:r>
+              <a:rPr lang="en-US" sz="1400" dirty="0">
+                <a:solidFill>
+                  <a:schemeClr val="tx2"/>
+                </a:solidFill>
+              </a:rPr>
+              <a:t>Red is the top 8 of the CSM's book, yellow the next 16. Every CSM always has a week of red.</a:t>
+            </a:r>
+            <a:endParaRPr lang="en-US" sz="1400" dirty="0"/>
+          </a:p>
+          <a:p>
+            <a:pPr indent="0" marL="0">
+              <a:buNone/>
+            </a:pPr>
+            <a:endParaRPr lang="en-US" sz="1400" dirty="0"/>
+          </a:p>
+          <a:p>
+            <a:pPr indent="0" marL="0">
+              <a:buNone/>
+            </a:pPr>
+            <a:r>
+              <a:rPr lang="en-US" sz="1400" dirty="0">
+                <a:solidFill>
+                  <a:schemeClr val="tx2"/>
+                </a:solidFill>
+              </a:rPr>
+              <a:t>Fixed probability bands drift with every retrain. Probability and ARR stay visible as columns.</a:t>
+            </a:r>
+            <a:endParaRPr lang="en-US" sz="1400" dirty="0"/>
+          </a:p>
+        </p:txBody>
+      </p:sp>
+      <p:sp>
+        <p:nvSpPr>
+          <p:cNvPr id="11" name="card Rank by ARR at risk"/>
+          <p:cNvSpPr/>
+          <p:nvPr/>
+        </p:nvSpPr>
+        <p:spPr>
+          <a:xfrm>
+            <a:off x="8046720" y="1463040"/>
+            <a:ext cx="3520440" cy="3566160"/>
+          </a:xfrm>
+          <a:prstGeom prst="roundRect">
+            <a:avLst>
+              <a:gd name="adj" fmla="val 2078"/>
+            </a:avLst>
+          </a:prstGeom>
+          <a:solidFill>
+            <a:schemeClr val="bg2"/>
+          </a:solidFill>
+          <a:ln w="12700">
+            <a:solidFill>
+              <a:schemeClr val="bg2"/>
+            </a:solidFill>
+            <a:prstDash val="solid"/>
+          </a:ln>
+        </p:spPr>
+      </p:sp>
+      <p:sp>
+        <p:nvSpPr>
+          <p:cNvPr id="12" name="Shape 10"/>
+          <p:cNvSpPr/>
+          <p:nvPr/>
+        </p:nvSpPr>
+        <p:spPr>
+          <a:xfrm>
+            <a:off x="8275320" y="1719072"/>
+            <a:ext cx="292608" cy="292608"/>
+          </a:xfrm>
+          <a:prstGeom prst="ellipse">
+            <a:avLst/>
+          </a:prstGeom>
+          <a:solidFill>
+            <a:schemeClr val="accent5"/>
+          </a:solidFill>
+          <a:ln w="12700">
+            <a:solidFill>
+              <a:schemeClr val="accent5"/>
+            </a:solidFill>
+            <a:prstDash val="solid"/>
+          </a:ln>
+        </p:spPr>
+      </p:sp>
+      <p:sp>
+        <p:nvSpPr>
+          <p:cNvPr id="13" name="Text 11"/>
+          <p:cNvSpPr txBox="1"/>
+          <p:nvPr/>
+        </p:nvSpPr>
+        <p:spPr>
+          <a:xfrm>
+            <a:off x="8686800" y="1627632"/>
+            <a:ext cx="2697480" cy="457200"/>
+          </a:xfrm>
+          <a:prstGeom prst="rect">
+            <a:avLst/>
+          </a:prstGeom>
+          <a:noFill/>
+          <a:ln/>
+        </p:spPr>
+        <p:txBody>
+          <a:bodyPr wrap="square" lIns="1524" tIns="1524" rIns="1524" bIns="1524" rtlCol="0" anchor="ctr"/>
+          <a:lstStyle/>
+          <a:p>
+            <a:pPr indent="0" marL="0">
+              <a:buNone/>
+            </a:pPr>
+            <a:r>
+              <a:rPr lang="en-US" sz="1800" b="1" dirty="0">
+                <a:solidFill>
+                  <a:schemeClr val="tx1"/>
+                </a:solidFill>
+              </a:rPr>
+              <a:t>Rank by ARR at risk</a:t>
+            </a:r>
+            <a:endParaRPr lang="en-US" sz="1800" dirty="0"/>
+          </a:p>
+        </p:txBody>
+      </p:sp>
+      <p:sp>
+        <p:nvSpPr>
+          <p:cNvPr id="14" name="Text 12"/>
+          <p:cNvSpPr txBox="1"/>
+          <p:nvPr/>
+        </p:nvSpPr>
+        <p:spPr>
+          <a:xfrm>
+            <a:off x="8275320" y="2176272"/>
+            <a:ext cx="3063240" cy="2697480"/>
+          </a:xfrm>
+          <a:prstGeom prst="rect">
+            <a:avLst/>
+          </a:prstGeom>
+          <a:noFill/>
+          <a:ln/>
+        </p:spPr>
+        <p:txBody>
+          <a:bodyPr wrap="square" lIns="1524" tIns="1524" rIns="1524" bIns="1524" rtlCol="0" anchor="t"/>
+          <a:lstStyle/>
+          <a:p>
+            <a:pPr indent="0" marL="0">
+              <a:buNone/>
+            </a:pPr>
+            <a:r>
+              <a:rPr lang="en-US" sz="1400" dirty="0">
+                <a:solidFill>
+                  <a:schemeClr val="tx2"/>
+                </a:solidFill>
+              </a:rPr>
+              <a:t>A $2k account at 60% should not outrank a $200k account at 50%. Rank score is probability x ARR, with one-click re-sort.</a:t>
+            </a:r>
+            <a:endParaRPr lang="en-US" sz="1400" dirty="0"/>
+          </a:p>
+          <a:p>
+            <a:pPr indent="0" marL="0">
+              <a:buNone/>
+            </a:pPr>
+            <a:endParaRPr lang="en-US" sz="1400" dirty="0"/>
+          </a:p>
+          <a:p>
+            <a:pPr indent="0" marL="0">
+              <a:buNone/>
+            </a:pPr>
+            <a:r>
+              <a:rPr lang="en-US" sz="1400" dirty="0">
+                <a:solidFill>
+                  <a:schemeClr val="tx2"/>
+                </a:solidFill>
+              </a:rPr>
+              <a:t>Label: the next renewal's outcome, so accounts far from renewal still get early warning.</a:t>
+            </a:r>
+            <a:endParaRPr lang="en-US" sz="1400" dirty="0"/>
+          </a:p>
+        </p:txBody>
+      </p:sp>
+      <p:sp>
+        <p:nvSpPr>
+          <p:cNvPr id="25" name="Slide Number Placeholder 0"/>
+          <p:cNvSpPr>
+            <a:spLocks noGrp="1"/>
+          </p:cNvSpPr>
+          <p:nvPr>
+            <p:ph type="sldNum" sz="quarter" idx="4294967295"/>
+          </p:nvPr>
+        </p:nvSpPr>
+        <p:spPr>
+          <a:xfrm>
+            <a:off x="11247120" y="6400800"/>
+            <a:ext cx="548640" cy="274320"/>
+          </a:xfrm>
+          <a:prstGeom prst="rect">
+            <a:avLst/>
+          </a:prstGeom>
+          <a:extLst>
+            <a:ext uri="{C572A759-6A51-4108-AA02-DFA0A04FC94B}">
+              <ma14:wrappingTextBoxFlag xmlns:ma14="http://schemas.microsoft.com/office/mac/drawingml/2011/main" val="0"/>
+            </a:ext>
+          </a:extLst>
+        </p:spPr>
+        <p:txBody>
+          <a:bodyPr/>
+          <a:lstStyle>
+            <a:lvl1pPr>
+              <a:defRPr sz="1000">
+                <a:solidFill>
+                  <a:schemeClr val="accent6"/>
+                </a:solidFill>
+              </a:defRPr>
+            </a:lvl1pPr>
+          </a:lstStyle>
+          <a:p>
+            <a:pPr algn="r"/>
+            <a:fld id="{F7021451-1387-4CA6-816F-3879F97B5CBC}" type="slidenum">
+              <a:rPr b="0" lang="en-US"/>
+              <a:t>6</a:t>
+            </a:fld>
+            <a:endParaRPr lang="en-US"/>
+          </a:p>
+        </p:txBody>
+      </p:sp>
+    </p:spTree>
+  </p:cSld>
+  <p:clrMapOvr>
+    <a:masterClrMapping/>
+  </p:clrMapOvr>
+</p:sld>
+</file>
+
+<file path=ppt/slides/slide7.xml><?xml version="1.0" encoding="utf-8"?>
+<p:sld xmlns:a="http://schemas.openxmlformats.org/drawingml/2006/main" xmlns:r="http://schemas.openxmlformats.org/officeDocument/2006/relationships" xmlns:p="http://schemas.openxmlformats.org/presentationml/2006/main">
+  <p:cSld name="Slide 7">
+    <p:spTree>
+      <p:nvGrpSpPr>
+        <p:cNvPr id="1" name=""/>
+        <p:cNvGrpSpPr/>
+        <p:nvPr/>
+      </p:nvGrpSpPr>
+      <p:grpSpPr>
+        <a:xfrm>
+          <a:off x="0" y="0"/>
+          <a:ext cx="0" cy="0"/>
+          <a:chOff x="0" y="0"/>
+          <a:chExt cx="0" cy="0"/>
+        </a:xfrm>
+      </p:grpSpPr>
+      <p:sp>
+        <p:nvSpPr>
+          <p:cNvPr id="2" name="Text 0"/>
+          <p:cNvSpPr/>
+          <p:nvPr>
+            <p:ph idx="100" type="title" hasCustomPrompt="1"/>
+          </p:nvPr>
+        </p:nvSpPr>
+        <p:spPr>
+          <a:xfrm>
+            <a:off x="548640" y="320040"/>
+            <a:ext cx="11064240" cy="822960"/>
+          </a:xfrm>
+          <a:prstGeom prst="rect">
+            <a:avLst/>
+          </a:prstGeom>
+          <a:noFill/>
+          <a:ln/>
+        </p:spPr>
+        <p:txBody>
+          <a:bodyPr wrap="square" rtlCol="0" anchor="ctr"/>
+          <a:lstStyle/>
+          <a:p>
+            <a:pPr algn="l" indent="0" marL="0">
+              <a:buNone/>
+            </a:pPr>
+            <a:r>
+              <a:rPr lang="en-US" sz="3200" b="1" dirty="0">
+                <a:solidFill>
+                  <a:schemeClr val="tx1"/>
+                </a:solidFill>
+              </a:rPr>
               <a:t>Where the build diverged from the plan, honestly</a:t>
             </a:r>
             <a:endParaRPr lang="en-US" sz="3200" dirty="0"/>
@@ -4108,7 +5519,7 @@
       </p:sp>
       <p:graphicFrame>
         <p:nvGraphicFramePr>
-          <p:cNvPr id="6" name="Table 0"/>
+          <p:cNvPr id="8" name="Table 0"/>
           <p:cNvGraphicFramePr>
             <a:graphicFrameLocks noGrp="1"/>
           </p:cNvGraphicFramePr>
@@ -4640,7 +6051,7 @@
                             <a:schemeClr val="tx1"/>
                           </a:solidFill>
                         </a:rPr>
-                        <a:t>Kept by a rule: switch only for a clear win on 100+ validation cycles</a:t>
+                        <a:t>Kept by a margin rule I set after the first run showed a tie; either is defensible</a:t>
                       </a:r>
                       <a:endParaRPr lang="en-US" sz="1500" dirty="0"/>
                     </a:p>
@@ -4764,7 +6175,7 @@
                             <a:schemeClr val="tx1"/>
                           </a:solidFill>
                         </a:rPr>
-                        <a:t>Cut</a:t>
+                        <a:t>A 2-sentence summary, every number checked</a:t>
                       </a:r>
                       <a:endParaRPr lang="en-US" sz="1500" dirty="0"/>
                     </a:p>
@@ -4825,7 +6236,7 @@
                             <a:schemeClr val="tx1"/>
                           </a:solidFill>
                         </a:rPr>
-                        <a:t>First in the cut order; the template says only what the model computed</a:t>
+                        <a:t>Runs after the night, sees only the reasons; off until a key is set</a:t>
                       </a:r>
                       <a:endParaRPr lang="en-US" sz="1500" dirty="0"/>
                     </a:p>
@@ -5286,1157 +6697,6 @@
             <a:pPr algn="r"/>
             <a:fld id="{F7021451-1387-4CA6-816F-3879F97B5CBC}" type="slidenum">
               <a:rPr b="0" lang="en-US"/>
-              <a:t>5</a:t>
-            </a:fld>
-            <a:endParaRPr lang="en-US"/>
-          </a:p>
-        </p:txBody>
-      </p:sp>
-    </p:spTree>
-  </p:cSld>
-  <p:clrMapOvr>
-    <a:masterClrMapping/>
-  </p:clrMapOvr>
-</p:sld>
-</file>
-
-<file path=ppt/slides/slide6.xml><?xml version="1.0" encoding="utf-8"?>
-<p:sld xmlns:a="http://schemas.openxmlformats.org/drawingml/2006/main" xmlns:r="http://schemas.openxmlformats.org/officeDocument/2006/relationships" xmlns:p="http://schemas.openxmlformats.org/presentationml/2006/main">
-  <p:cSld name="Slide 6">
-    <p:spTree>
-      <p:nvGrpSpPr>
-        <p:cNvPr id="1" name=""/>
-        <p:cNvGrpSpPr/>
-        <p:nvPr/>
-      </p:nvGrpSpPr>
-      <p:grpSpPr>
-        <a:xfrm>
-          <a:off x="0" y="0"/>
-          <a:ext cx="0" cy="0"/>
-          <a:chOff x="0" y="0"/>
-          <a:chExt cx="0" cy="0"/>
-        </a:xfrm>
-      </p:grpSpPr>
-      <p:sp>
-        <p:nvSpPr>
-          <p:cNvPr id="2" name="Text 0"/>
-          <p:cNvSpPr/>
-          <p:nvPr>
-            <p:ph idx="100" type="title" hasCustomPrompt="1"/>
-          </p:nvPr>
-        </p:nvSpPr>
-        <p:spPr>
-          <a:xfrm>
-            <a:off x="548640" y="320040"/>
-            <a:ext cx="11064240" cy="822960"/>
-          </a:xfrm>
-          <a:prstGeom prst="rect">
-            <a:avLst/>
-          </a:prstGeom>
-          <a:noFill/>
-          <a:ln/>
-        </p:spPr>
-        <p:txBody>
-          <a:bodyPr wrap="square" rtlCol="0" anchor="ctr"/>
-          <a:lstStyle/>
-          <a:p>
-            <a:pPr algn="l" indent="0" marL="0">
-              <a:buNone/>
-            </a:pPr>
-            <a:r>
-              <a:rPr lang="en-US" sz="3200" b="1" dirty="0">
-                <a:solidFill>
-                  <a:schemeClr val="tx1"/>
-                </a:solidFill>
-              </a:rPr>
-              <a:t>Beats rules and the calendar; ties logistic regression</a:t>
-            </a:r>
-            <a:endParaRPr lang="en-US" sz="3200" dirty="0"/>
-          </a:p>
-        </p:txBody>
-      </p:sp>
-      <p:graphicFrame>
-        <p:nvGraphicFramePr>
-          <p:cNvPr id="3" name="Chart 0" descr=""/>
-          <p:cNvGraphicFramePr/>
-          <p:nvPr/>
-        </p:nvGraphicFramePr>
-        <p:xfrm>
-          <a:off x="548640" y="1325880"/>
-          <a:ext cx="6766560" cy="4937760"/>
-        </p:xfrm>
-        <a:graphic xmlns:a="http://schemas.openxmlformats.org/drawingml/2006/main">
-          <a:graphicData uri="http://schemas.openxmlformats.org/drawingml/2006/chart">
-            <c:chart xmlns:c="http://schemas.openxmlformats.org/drawingml/2006/chart" r:id="rId1"/>
-          </a:graphicData>
-        </a:graphic>
-      </p:graphicFrame>
-      <p:sp>
-        <p:nvSpPr>
-          <p:cNvPr id="4" name="Text 1"/>
-          <p:cNvSpPr txBox="1"/>
-          <p:nvPr/>
-        </p:nvSpPr>
-        <p:spPr>
-          <a:xfrm>
-            <a:off x="7680960" y="1371600"/>
-            <a:ext cx="1737360" cy="914400"/>
-          </a:xfrm>
-          <a:prstGeom prst="rect">
-            <a:avLst/>
-          </a:prstGeom>
-          <a:noFill/>
-          <a:ln/>
-        </p:spPr>
-        <p:txBody>
-          <a:bodyPr wrap="square" lIns="1524" tIns="1524" rIns="1524" bIns="1524" rtlCol="0" anchor="ctr"/>
-          <a:lstStyle/>
-          <a:p>
-            <a:pPr indent="0" marL="0">
-              <a:buNone/>
-            </a:pPr>
-            <a:r>
-              <a:rPr lang="en-US" sz="3000" b="1" dirty="0">
-                <a:solidFill>
-                  <a:schemeClr val="accent1"/>
-                </a:solidFill>
-                <a:latin typeface="Cambria" pitchFamily="34" charset="0"/>
-                <a:ea typeface="Cambria" pitchFamily="34" charset="-122"/>
-                <a:cs typeface="Cambria" pitchFamily="34" charset="-120"/>
-              </a:rPr>
-              <a:t>21.8%</a:t>
-            </a:r>
-            <a:endParaRPr lang="en-US" sz="3000" dirty="0"/>
-          </a:p>
-        </p:txBody>
-      </p:sp>
-      <p:sp>
-        <p:nvSpPr>
-          <p:cNvPr id="5" name="Text 2"/>
-          <p:cNvSpPr txBox="1"/>
-          <p:nvPr/>
-        </p:nvSpPr>
-        <p:spPr>
-          <a:xfrm>
-            <a:off x="9418320" y="1417320"/>
-            <a:ext cx="2286000" cy="868680"/>
-          </a:xfrm>
-          <a:prstGeom prst="rect">
-            <a:avLst/>
-          </a:prstGeom>
-          <a:noFill/>
-          <a:ln/>
-        </p:spPr>
-        <p:txBody>
-          <a:bodyPr wrap="square" lIns="1524" tIns="1524" rIns="1524" bIns="1524" rtlCol="0" anchor="ctr"/>
-          <a:lstStyle/>
-          <a:p>
-            <a:pPr indent="0" marL="0">
-              <a:buNone/>
-            </a:pPr>
-            <a:r>
-              <a:rPr lang="en-US" sz="1400" dirty="0">
-                <a:solidFill>
-                  <a:schemeClr val="tx2"/>
-                </a:solidFill>
-              </a:rPr>
-              <a:t>recall@8 per CSM-week (oracle 23.6%)</a:t>
-            </a:r>
-            <a:endParaRPr lang="en-US" sz="1400" dirty="0"/>
-          </a:p>
-        </p:txBody>
-      </p:sp>
-      <p:sp>
-        <p:nvSpPr>
-          <p:cNvPr id="6" name="Text 3"/>
-          <p:cNvSpPr txBox="1"/>
-          <p:nvPr/>
-        </p:nvSpPr>
-        <p:spPr>
-          <a:xfrm>
-            <a:off x="7680960" y="2606040"/>
-            <a:ext cx="1737360" cy="914400"/>
-          </a:xfrm>
-          <a:prstGeom prst="rect">
-            <a:avLst/>
-          </a:prstGeom>
-          <a:noFill/>
-          <a:ln/>
-        </p:spPr>
-        <p:txBody>
-          <a:bodyPr wrap="square" lIns="1524" tIns="1524" rIns="1524" bIns="1524" rtlCol="0" anchor="ctr"/>
-          <a:lstStyle/>
-          <a:p>
-            <a:pPr indent="0" marL="0">
-              <a:buNone/>
-            </a:pPr>
-            <a:r>
-              <a:rPr lang="en-US" sz="3000" b="1" dirty="0">
-                <a:solidFill>
-                  <a:schemeClr val="accent1"/>
-                </a:solidFill>
-                <a:latin typeface="Cambria" pitchFamily="34" charset="0"/>
-                <a:ea typeface="Cambria" pitchFamily="34" charset="-122"/>
-                <a:cs typeface="Cambria" pitchFamily="34" charset="-120"/>
-              </a:rPr>
-              <a:t>+0.009</a:t>
-            </a:r>
-            <a:endParaRPr lang="en-US" sz="3000" dirty="0"/>
-          </a:p>
-        </p:txBody>
-      </p:sp>
-      <p:sp>
-        <p:nvSpPr>
-          <p:cNvPr id="7" name="Text 4"/>
-          <p:cNvSpPr txBox="1"/>
-          <p:nvPr/>
-        </p:nvSpPr>
-        <p:spPr>
-          <a:xfrm>
-            <a:off x="9418320" y="2651760"/>
-            <a:ext cx="2286000" cy="868680"/>
-          </a:xfrm>
-          <a:prstGeom prst="rect">
-            <a:avLst/>
-          </a:prstGeom>
-          <a:noFill/>
-          <a:ln/>
-        </p:spPr>
-        <p:txBody>
-          <a:bodyPr wrap="square" lIns="1524" tIns="1524" rIns="1524" bIns="1524" rtlCol="0" anchor="ctr"/>
-          <a:lstStyle/>
-          <a:p>
-            <a:pPr indent="0" marL="0">
-              <a:buNone/>
-            </a:pPr>
-            <a:r>
-              <a:rPr lang="en-US" sz="1400" dirty="0">
-                <a:solidFill>
-                  <a:schemeClr val="tx2"/>
-                </a:solidFill>
-              </a:rPr>
-              <a:t>LightGBM minus LR, 95% CI −0.009 to +0.028</a:t>
-            </a:r>
-            <a:endParaRPr lang="en-US" sz="1400" dirty="0"/>
-          </a:p>
-        </p:txBody>
-      </p:sp>
-      <p:sp>
-        <p:nvSpPr>
-          <p:cNvPr id="8" name="Text 5"/>
-          <p:cNvSpPr txBox="1"/>
-          <p:nvPr/>
-        </p:nvSpPr>
-        <p:spPr>
-          <a:xfrm>
-            <a:off x="7680960" y="3840480"/>
-            <a:ext cx="1737360" cy="914400"/>
-          </a:xfrm>
-          <a:prstGeom prst="rect">
-            <a:avLst/>
-          </a:prstGeom>
-          <a:noFill/>
-          <a:ln/>
-        </p:spPr>
-        <p:txBody>
-          <a:bodyPr wrap="square" lIns="1524" tIns="1524" rIns="1524" bIns="1524" rtlCol="0" anchor="ctr"/>
-          <a:lstStyle/>
-          <a:p>
-            <a:pPr indent="0" marL="0">
-              <a:buNone/>
-            </a:pPr>
-            <a:r>
-              <a:rPr lang="en-US" sz="3000" b="1" dirty="0">
-                <a:solidFill>
-                  <a:schemeClr val="accent1"/>
-                </a:solidFill>
-                <a:latin typeface="Cambria" pitchFamily="34" charset="0"/>
-                <a:ea typeface="Cambria" pitchFamily="34" charset="-122"/>
-                <a:cs typeface="Cambria" pitchFamily="34" charset="-120"/>
-              </a:rPr>
-              <a:t>0.8%</a:t>
-            </a:r>
-            <a:endParaRPr lang="en-US" sz="3000" dirty="0"/>
-          </a:p>
-        </p:txBody>
-      </p:sp>
-      <p:sp>
-        <p:nvSpPr>
-          <p:cNvPr id="9" name="Text 6"/>
-          <p:cNvSpPr txBox="1"/>
-          <p:nvPr/>
-        </p:nvSpPr>
-        <p:spPr>
-          <a:xfrm>
-            <a:off x="9418320" y="3886200"/>
-            <a:ext cx="2286000" cy="868680"/>
-          </a:xfrm>
-          <a:prstGeom prst="rect">
-            <a:avLst/>
-          </a:prstGeom>
-          <a:noFill/>
-          <a:ln/>
-        </p:spPr>
-        <p:txBody>
-          <a:bodyPr wrap="square" lIns="1524" tIns="1524" rIns="1524" bIns="1524" rtlCol="0" anchor="ctr"/>
-          <a:lstStyle/>
-          <a:p>
-            <a:pPr indent="0" marL="0">
-              <a:buNone/>
-            </a:pPr>
-            <a:r>
-              <a:rPr lang="en-US" sz="1400" dirty="0">
-                <a:solidFill>
-                  <a:schemeClr val="tx2"/>
-                </a:solidFill>
-              </a:rPr>
-              <a:t>share of the model that is days to renewal</a:t>
-            </a:r>
-            <a:endParaRPr lang="en-US" sz="1400" dirty="0"/>
-          </a:p>
-        </p:txBody>
-      </p:sp>
-      <p:sp>
-        <p:nvSpPr>
-          <p:cNvPr id="10" name="Text 7"/>
-          <p:cNvSpPr txBox="1"/>
-          <p:nvPr/>
-        </p:nvSpPr>
-        <p:spPr>
-          <a:xfrm>
-            <a:off x="7680960" y="5074920"/>
-            <a:ext cx="1737360" cy="914400"/>
-          </a:xfrm>
-          <a:prstGeom prst="rect">
-            <a:avLst/>
-          </a:prstGeom>
-          <a:noFill/>
-          <a:ln/>
-        </p:spPr>
-        <p:txBody>
-          <a:bodyPr wrap="square" lIns="1524" tIns="1524" rIns="1524" bIns="1524" rtlCol="0" anchor="ctr"/>
-          <a:lstStyle/>
-          <a:p>
-            <a:pPr indent="0" marL="0">
-              <a:buNone/>
-            </a:pPr>
-            <a:r>
-              <a:rPr lang="en-US" sz="3000" b="1" dirty="0">
-                <a:solidFill>
-                  <a:schemeClr val="accent1"/>
-                </a:solidFill>
-                <a:latin typeface="Cambria" pitchFamily="34" charset="0"/>
-                <a:ea typeface="Cambria" pitchFamily="34" charset="-122"/>
-                <a:cs typeface="Cambria" pitchFamily="34" charset="-120"/>
-              </a:rPr>
-              <a:t>0.48</a:t>
-            </a:r>
-            <a:endParaRPr lang="en-US" sz="3000" dirty="0"/>
-          </a:p>
-        </p:txBody>
-      </p:sp>
-      <p:sp>
-        <p:nvSpPr>
-          <p:cNvPr id="11" name="Text 8"/>
-          <p:cNvSpPr txBox="1"/>
-          <p:nvPr/>
-        </p:nvSpPr>
-        <p:spPr>
-          <a:xfrm>
-            <a:off x="9418320" y="5120640"/>
-            <a:ext cx="2286000" cy="868680"/>
-          </a:xfrm>
-          <a:prstGeom prst="rect">
-            <a:avLst/>
-          </a:prstGeom>
-          <a:noFill/>
-          <a:ln/>
-        </p:spPr>
-        <p:txBody>
-          <a:bodyPr wrap="square" lIns="1524" tIns="1524" rIns="1524" bIns="1524" rtlCol="0" anchor="ctr"/>
-          <a:lstStyle/>
-          <a:p>
-            <a:pPr indent="0" marL="0">
-              <a:buNone/>
-            </a:pPr>
-            <a:r>
-              <a:rPr lang="en-US" sz="1400" dirty="0">
-                <a:solidFill>
-                  <a:schemeClr val="tx2"/>
-                </a:solidFill>
-              </a:rPr>
-              <a:t>shuffled-label AUC: no leakage</a:t>
-            </a:r>
-            <a:endParaRPr lang="en-US" sz="1400" dirty="0"/>
-          </a:p>
-        </p:txBody>
-      </p:sp>
-      <p:sp>
-        <p:nvSpPr>
-          <p:cNvPr id="25" name="Slide Number Placeholder 0"/>
-          <p:cNvSpPr>
-            <a:spLocks noGrp="1"/>
-          </p:cNvSpPr>
-          <p:nvPr>
-            <p:ph type="sldNum" sz="quarter" idx="4294967295"/>
-          </p:nvPr>
-        </p:nvSpPr>
-        <p:spPr>
-          <a:xfrm>
-            <a:off x="11247120" y="6400800"/>
-            <a:ext cx="548640" cy="274320"/>
-          </a:xfrm>
-          <a:prstGeom prst="rect">
-            <a:avLst/>
-          </a:prstGeom>
-          <a:extLst>
-            <a:ext uri="{C572A759-6A51-4108-AA02-DFA0A04FC94B}">
-              <ma14:wrappingTextBoxFlag xmlns:ma14="http://schemas.microsoft.com/office/mac/drawingml/2011/main" val="0"/>
-            </a:ext>
-          </a:extLst>
-        </p:spPr>
-        <p:txBody>
-          <a:bodyPr/>
-          <a:lstStyle>
-            <a:lvl1pPr>
-              <a:defRPr sz="1000">
-                <a:solidFill>
-                  <a:schemeClr val="accent6"/>
-                </a:solidFill>
-              </a:defRPr>
-            </a:lvl1pPr>
-          </a:lstStyle>
-          <a:p>
-            <a:pPr algn="r"/>
-            <a:fld id="{F7021451-1387-4CA6-816F-3879F97B5CBC}" type="slidenum">
-              <a:rPr b="0" lang="en-US"/>
-              <a:t>6</a:t>
-            </a:fld>
-            <a:endParaRPr lang="en-US"/>
-          </a:p>
-        </p:txBody>
-      </p:sp>
-    </p:spTree>
-  </p:cSld>
-  <p:clrMapOvr>
-    <a:masterClrMapping/>
-  </p:clrMapOvr>
-</p:sld>
-</file>
-
-<file path=ppt/slides/slide7.xml><?xml version="1.0" encoding="utf-8"?>
-<p:sld xmlns:a="http://schemas.openxmlformats.org/drawingml/2006/main" xmlns:r="http://schemas.openxmlformats.org/officeDocument/2006/relationships" xmlns:p="http://schemas.openxmlformats.org/presentationml/2006/main">
-  <p:cSld name="Slide 7">
-    <p:spTree>
-      <p:nvGrpSpPr>
-        <p:cNvPr id="1" name=""/>
-        <p:cNvGrpSpPr/>
-        <p:nvPr/>
-      </p:nvGrpSpPr>
-      <p:grpSpPr>
-        <a:xfrm>
-          <a:off x="0" y="0"/>
-          <a:ext cx="0" cy="0"/>
-          <a:chOff x="0" y="0"/>
-          <a:chExt cx="0" cy="0"/>
-        </a:xfrm>
-      </p:grpSpPr>
-      <p:sp>
-        <p:nvSpPr>
-          <p:cNvPr id="2" name="Text 0"/>
-          <p:cNvSpPr/>
-          <p:nvPr>
-            <p:ph idx="100" type="title" hasCustomPrompt="1"/>
-          </p:nvPr>
-        </p:nvSpPr>
-        <p:spPr>
-          <a:xfrm>
-            <a:off x="548640" y="320040"/>
-            <a:ext cx="11064240" cy="822960"/>
-          </a:xfrm>
-          <a:prstGeom prst="rect">
-            <a:avLst/>
-          </a:prstGeom>
-          <a:noFill/>
-          <a:ln/>
-        </p:spPr>
-        <p:txBody>
-          <a:bodyPr wrap="square" rtlCol="0" anchor="ctr"/>
-          <a:lstStyle/>
-          <a:p>
-            <a:pPr algn="l" indent="0" marL="0">
-              <a:buNone/>
-            </a:pPr>
-            <a:r>
-              <a:rPr lang="en-US" sz="3200" b="1" dirty="0">
-                <a:solidFill>
-                  <a:schemeClr val="tx1"/>
-                </a:solidFill>
-              </a:rPr>
-              <a:t>The night runs itself, and every step is a row</a:t>
-            </a:r>
-            <a:endParaRPr lang="en-US" sz="3200" dirty="0"/>
-          </a:p>
-        </p:txBody>
-      </p:sp>
-      <p:sp>
-        <p:nvSpPr>
-          <p:cNvPr id="3" name="stage Ingest"/>
-          <p:cNvSpPr/>
-          <p:nvPr/>
-        </p:nvSpPr>
-        <p:spPr>
-          <a:xfrm>
-            <a:off x="548640" y="1463040"/>
-            <a:ext cx="1417320" cy="822960"/>
-          </a:xfrm>
-          <a:prstGeom prst="roundRect">
-            <a:avLst>
-              <a:gd name="adj" fmla="val 8889"/>
-            </a:avLst>
-          </a:prstGeom>
-          <a:solidFill>
-            <a:schemeClr val="tx2"/>
-          </a:solidFill>
-          <a:ln w="12700">
-            <a:solidFill>
-              <a:schemeClr val="tx2"/>
-            </a:solidFill>
-            <a:prstDash val="solid"/>
-          </a:ln>
-        </p:spPr>
-      </p:sp>
-      <p:sp>
-        <p:nvSpPr>
-          <p:cNvPr id="4" name="Text 2"/>
-          <p:cNvSpPr txBox="1"/>
-          <p:nvPr/>
-        </p:nvSpPr>
-        <p:spPr>
-          <a:xfrm>
-            <a:off x="548640" y="1463040"/>
-            <a:ext cx="1417320" cy="822960"/>
-          </a:xfrm>
-          <a:prstGeom prst="rect">
-            <a:avLst/>
-          </a:prstGeom>
-          <a:noFill/>
-          <a:ln/>
-        </p:spPr>
-        <p:txBody>
-          <a:bodyPr wrap="square" lIns="635" tIns="635" rIns="635" bIns="635" rtlCol="0" anchor="ctr"/>
-          <a:lstStyle/>
-          <a:p>
-            <a:pPr algn="ctr" indent="0" marL="0">
-              <a:buNone/>
-            </a:pPr>
-            <a:r>
-              <a:rPr lang="en-US" sz="1400" b="1" dirty="0">
-                <a:solidFill>
-                  <a:schemeClr val="bg1"/>
-                </a:solidFill>
-              </a:rPr>
-              <a:t>Ingest</a:t>
-            </a:r>
-            <a:endParaRPr lang="en-US" sz="1400" dirty="0"/>
-          </a:p>
-        </p:txBody>
-      </p:sp>
-      <p:sp>
-        <p:nvSpPr>
-          <p:cNvPr id="5" name="stage Snapshot"/>
-          <p:cNvSpPr/>
-          <p:nvPr/>
-        </p:nvSpPr>
-        <p:spPr>
-          <a:xfrm>
-            <a:off x="2148840" y="1463040"/>
-            <a:ext cx="1417320" cy="822960"/>
-          </a:xfrm>
-          <a:prstGeom prst="roundRect">
-            <a:avLst>
-              <a:gd name="adj" fmla="val 8889"/>
-            </a:avLst>
-          </a:prstGeom>
-          <a:solidFill>
-            <a:schemeClr val="tx2"/>
-          </a:solidFill>
-          <a:ln w="12700">
-            <a:solidFill>
-              <a:schemeClr val="tx2"/>
-            </a:solidFill>
-            <a:prstDash val="solid"/>
-          </a:ln>
-        </p:spPr>
-      </p:sp>
-      <p:sp>
-        <p:nvSpPr>
-          <p:cNvPr id="6" name="Text 4"/>
-          <p:cNvSpPr txBox="1"/>
-          <p:nvPr/>
-        </p:nvSpPr>
-        <p:spPr>
-          <a:xfrm>
-            <a:off x="2148840" y="1463040"/>
-            <a:ext cx="1417320" cy="822960"/>
-          </a:xfrm>
-          <a:prstGeom prst="rect">
-            <a:avLst/>
-          </a:prstGeom>
-          <a:noFill/>
-          <a:ln/>
-        </p:spPr>
-        <p:txBody>
-          <a:bodyPr wrap="square" lIns="635" tIns="635" rIns="635" bIns="635" rtlCol="0" anchor="ctr"/>
-          <a:lstStyle/>
-          <a:p>
-            <a:pPr algn="ctr" indent="0" marL="0">
-              <a:buNone/>
-            </a:pPr>
-            <a:r>
-              <a:rPr lang="en-US" sz="1400" b="1" dirty="0">
-                <a:solidFill>
-                  <a:schemeClr val="bg1"/>
-                </a:solidFill>
-              </a:rPr>
-              <a:t>Snapshot</a:t>
-            </a:r>
-            <a:endParaRPr lang="en-US" sz="1400" dirty="0"/>
-          </a:p>
-        </p:txBody>
-      </p:sp>
-      <p:sp>
-        <p:nvSpPr>
-          <p:cNvPr id="7" name="stage Score"/>
-          <p:cNvSpPr/>
-          <p:nvPr/>
-        </p:nvSpPr>
-        <p:spPr>
-          <a:xfrm>
-            <a:off x="3749040" y="1463040"/>
-            <a:ext cx="1417320" cy="822960"/>
-          </a:xfrm>
-          <a:prstGeom prst="roundRect">
-            <a:avLst>
-              <a:gd name="adj" fmla="val 8889"/>
-            </a:avLst>
-          </a:prstGeom>
-          <a:solidFill>
-            <a:schemeClr val="tx2"/>
-          </a:solidFill>
-          <a:ln w="12700">
-            <a:solidFill>
-              <a:schemeClr val="tx2"/>
-            </a:solidFill>
-            <a:prstDash val="solid"/>
-          </a:ln>
-        </p:spPr>
-      </p:sp>
-      <p:sp>
-        <p:nvSpPr>
-          <p:cNvPr id="8" name="Text 6"/>
-          <p:cNvSpPr txBox="1"/>
-          <p:nvPr/>
-        </p:nvSpPr>
-        <p:spPr>
-          <a:xfrm>
-            <a:off x="3749040" y="1463040"/>
-            <a:ext cx="1417320" cy="822960"/>
-          </a:xfrm>
-          <a:prstGeom prst="rect">
-            <a:avLst/>
-          </a:prstGeom>
-          <a:noFill/>
-          <a:ln/>
-        </p:spPr>
-        <p:txBody>
-          <a:bodyPr wrap="square" lIns="635" tIns="635" rIns="635" bIns="635" rtlCol="0" anchor="ctr"/>
-          <a:lstStyle/>
-          <a:p>
-            <a:pPr algn="ctr" indent="0" marL="0">
-              <a:buNone/>
-            </a:pPr>
-            <a:r>
-              <a:rPr lang="en-US" sz="1400" b="1" dirty="0">
-                <a:solidFill>
-                  <a:schemeClr val="bg1"/>
-                </a:solidFill>
-              </a:rPr>
-              <a:t>Score</a:t>
-            </a:r>
-            <a:endParaRPr lang="en-US" sz="1400" dirty="0"/>
-          </a:p>
-        </p:txBody>
-      </p:sp>
-      <p:sp>
-        <p:nvSpPr>
-          <p:cNvPr id="9" name="stage Gate"/>
-          <p:cNvSpPr/>
-          <p:nvPr/>
-        </p:nvSpPr>
-        <p:spPr>
-          <a:xfrm>
-            <a:off x="5349240" y="1463040"/>
-            <a:ext cx="1417320" cy="822960"/>
-          </a:xfrm>
-          <a:prstGeom prst="roundRect">
-            <a:avLst>
-              <a:gd name="adj" fmla="val 8889"/>
-            </a:avLst>
-          </a:prstGeom>
-          <a:solidFill>
-            <a:schemeClr val="accent1"/>
-          </a:solidFill>
-          <a:ln w="12700">
-            <a:solidFill>
-              <a:schemeClr val="accent1"/>
-            </a:solidFill>
-            <a:prstDash val="solid"/>
-          </a:ln>
-        </p:spPr>
-      </p:sp>
-      <p:sp>
-        <p:nvSpPr>
-          <p:cNvPr id="10" name="Text 8"/>
-          <p:cNvSpPr txBox="1"/>
-          <p:nvPr/>
-        </p:nvSpPr>
-        <p:spPr>
-          <a:xfrm>
-            <a:off x="5349240" y="1463040"/>
-            <a:ext cx="1417320" cy="822960"/>
-          </a:xfrm>
-          <a:prstGeom prst="rect">
-            <a:avLst/>
-          </a:prstGeom>
-          <a:noFill/>
-          <a:ln/>
-        </p:spPr>
-        <p:txBody>
-          <a:bodyPr wrap="square" lIns="635" tIns="635" rIns="635" bIns="635" rtlCol="0" anchor="ctr"/>
-          <a:lstStyle/>
-          <a:p>
-            <a:pPr algn="ctr" indent="0" marL="0">
-              <a:buNone/>
-            </a:pPr>
-            <a:r>
-              <a:rPr lang="en-US" sz="1400" b="1" dirty="0">
-                <a:solidFill>
-                  <a:schemeClr val="bg1"/>
-                </a:solidFill>
-              </a:rPr>
-              <a:t>Gate</a:t>
-            </a:r>
-            <a:endParaRPr lang="en-US" sz="1400" dirty="0"/>
-          </a:p>
-        </p:txBody>
-      </p:sp>
-      <p:sp>
-        <p:nvSpPr>
-          <p:cNvPr id="11" name="stage Transitions"/>
-          <p:cNvSpPr/>
-          <p:nvPr/>
-        </p:nvSpPr>
-        <p:spPr>
-          <a:xfrm>
-            <a:off x="6949440" y="1463040"/>
-            <a:ext cx="1417320" cy="822960"/>
-          </a:xfrm>
-          <a:prstGeom prst="roundRect">
-            <a:avLst>
-              <a:gd name="adj" fmla="val 8889"/>
-            </a:avLst>
-          </a:prstGeom>
-          <a:solidFill>
-            <a:schemeClr val="tx2"/>
-          </a:solidFill>
-          <a:ln w="12700">
-            <a:solidFill>
-              <a:schemeClr val="tx2"/>
-            </a:solidFill>
-            <a:prstDash val="solid"/>
-          </a:ln>
-        </p:spPr>
-      </p:sp>
-      <p:sp>
-        <p:nvSpPr>
-          <p:cNvPr id="12" name="Text 10"/>
-          <p:cNvSpPr txBox="1"/>
-          <p:nvPr/>
-        </p:nvSpPr>
-        <p:spPr>
-          <a:xfrm>
-            <a:off x="6949440" y="1463040"/>
-            <a:ext cx="1417320" cy="822960"/>
-          </a:xfrm>
-          <a:prstGeom prst="rect">
-            <a:avLst/>
-          </a:prstGeom>
-          <a:noFill/>
-          <a:ln/>
-        </p:spPr>
-        <p:txBody>
-          <a:bodyPr wrap="square" lIns="635" tIns="635" rIns="635" bIns="635" rtlCol="0" anchor="ctr"/>
-          <a:lstStyle/>
-          <a:p>
-            <a:pPr algn="ctr" indent="0" marL="0">
-              <a:buNone/>
-            </a:pPr>
-            <a:r>
-              <a:rPr lang="en-US" sz="1400" b="1" dirty="0">
-                <a:solidFill>
-                  <a:schemeClr val="bg1"/>
-                </a:solidFill>
-              </a:rPr>
-              <a:t>Transitions</a:t>
-            </a:r>
-            <a:endParaRPr lang="en-US" sz="1400" dirty="0"/>
-          </a:p>
-        </p:txBody>
-      </p:sp>
-      <p:sp>
-        <p:nvSpPr>
-          <p:cNvPr id="13" name="stage Policy + tasks"/>
-          <p:cNvSpPr/>
-          <p:nvPr/>
-        </p:nvSpPr>
-        <p:spPr>
-          <a:xfrm>
-            <a:off x="8549640" y="1463040"/>
-            <a:ext cx="1417320" cy="822960"/>
-          </a:xfrm>
-          <a:prstGeom prst="roundRect">
-            <a:avLst>
-              <a:gd name="adj" fmla="val 8889"/>
-            </a:avLst>
-          </a:prstGeom>
-          <a:solidFill>
-            <a:schemeClr val="tx2"/>
-          </a:solidFill>
-          <a:ln w="12700">
-            <a:solidFill>
-              <a:schemeClr val="tx2"/>
-            </a:solidFill>
-            <a:prstDash val="solid"/>
-          </a:ln>
-        </p:spPr>
-      </p:sp>
-      <p:sp>
-        <p:nvSpPr>
-          <p:cNvPr id="14" name="Text 12"/>
-          <p:cNvSpPr txBox="1"/>
-          <p:nvPr/>
-        </p:nvSpPr>
-        <p:spPr>
-          <a:xfrm>
-            <a:off x="8549640" y="1463040"/>
-            <a:ext cx="1417320" cy="822960"/>
-          </a:xfrm>
-          <a:prstGeom prst="rect">
-            <a:avLst/>
-          </a:prstGeom>
-          <a:noFill/>
-          <a:ln/>
-        </p:spPr>
-        <p:txBody>
-          <a:bodyPr wrap="square" lIns="635" tIns="635" rIns="635" bIns="635" rtlCol="0" anchor="ctr"/>
-          <a:lstStyle/>
-          <a:p>
-            <a:pPr algn="ctr" indent="0" marL="0">
-              <a:buNone/>
-            </a:pPr>
-            <a:r>
-              <a:rPr lang="en-US" sz="1400" b="1" dirty="0">
-                <a:solidFill>
-                  <a:schemeClr val="bg1"/>
-                </a:solidFill>
-              </a:rPr>
-              <a:t>Policy + tasks</a:t>
-            </a:r>
-            <a:endParaRPr lang="en-US" sz="1400" dirty="0"/>
-          </a:p>
-        </p:txBody>
-      </p:sp>
-      <p:sp>
-        <p:nvSpPr>
-          <p:cNvPr id="15" name="stage Escalation"/>
-          <p:cNvSpPr/>
-          <p:nvPr/>
-        </p:nvSpPr>
-        <p:spPr>
-          <a:xfrm>
-            <a:off x="10149840" y="1463040"/>
-            <a:ext cx="1417320" cy="822960"/>
-          </a:xfrm>
-          <a:prstGeom prst="roundRect">
-            <a:avLst>
-              <a:gd name="adj" fmla="val 8889"/>
-            </a:avLst>
-          </a:prstGeom>
-          <a:solidFill>
-            <a:schemeClr val="tx2"/>
-          </a:solidFill>
-          <a:ln w="12700">
-            <a:solidFill>
-              <a:schemeClr val="tx2"/>
-            </a:solidFill>
-            <a:prstDash val="solid"/>
-          </a:ln>
-        </p:spPr>
-      </p:sp>
-      <p:sp>
-        <p:nvSpPr>
-          <p:cNvPr id="16" name="Text 14"/>
-          <p:cNvSpPr txBox="1"/>
-          <p:nvPr/>
-        </p:nvSpPr>
-        <p:spPr>
-          <a:xfrm>
-            <a:off x="10149840" y="1463040"/>
-            <a:ext cx="1417320" cy="822960"/>
-          </a:xfrm>
-          <a:prstGeom prst="rect">
-            <a:avLst/>
-          </a:prstGeom>
-          <a:noFill/>
-          <a:ln/>
-        </p:spPr>
-        <p:txBody>
-          <a:bodyPr wrap="square" lIns="635" tIns="635" rIns="635" bIns="635" rtlCol="0" anchor="ctr"/>
-          <a:lstStyle/>
-          <a:p>
-            <a:pPr algn="ctr" indent="0" marL="0">
-              <a:buNone/>
-            </a:pPr>
-            <a:r>
-              <a:rPr lang="en-US" sz="1400" b="1" dirty="0">
-                <a:solidFill>
-                  <a:schemeClr val="bg1"/>
-                </a:solidFill>
-              </a:rPr>
-              <a:t>Escalation</a:t>
-            </a:r>
-            <a:endParaRPr lang="en-US" sz="1400" dirty="0"/>
-          </a:p>
-        </p:txBody>
-      </p:sp>
-      <p:sp>
-        <p:nvSpPr>
-          <p:cNvPr id="17" name="Text 15"/>
-          <p:cNvSpPr txBox="1"/>
-          <p:nvPr/>
-        </p:nvSpPr>
-        <p:spPr>
-          <a:xfrm>
-            <a:off x="548640" y="2468880"/>
-            <a:ext cx="11064240" cy="640080"/>
-          </a:xfrm>
-          <a:prstGeom prst="rect">
-            <a:avLst/>
-          </a:prstGeom>
-          <a:noFill/>
-          <a:ln/>
-        </p:spPr>
-        <p:txBody>
-          <a:bodyPr wrap="square" lIns="1524" tIns="1524" rIns="1524" bIns="1524" rtlCol="0" anchor="t"/>
-          <a:lstStyle/>
-          <a:p>
-            <a:pPr indent="0" marL="0">
-              <a:buNone/>
-            </a:pPr>
-            <a:r>
-              <a:rPr lang="en-US" sz="1500" dirty="0">
-                <a:solidFill>
-                  <a:schemeClr val="tx2"/>
-                </a:solidFill>
-              </a:rPr>
-              <a:t>A tripped data-quality gate rolls the night back: nothing after it is published, and the list keeps the last good night with a warning.</a:t>
-            </a:r>
-            <a:endParaRPr lang="en-US" sz="1500" dirty="0"/>
-          </a:p>
-        </p:txBody>
-      </p:sp>
-      <p:sp>
-        <p:nvSpPr>
-          <p:cNvPr id="18" name="Text 16"/>
-          <p:cNvSpPr txBox="1"/>
-          <p:nvPr/>
-        </p:nvSpPr>
-        <p:spPr>
-          <a:xfrm>
-            <a:off x="548640" y="3291840"/>
-            <a:ext cx="5486400" cy="2377440"/>
-          </a:xfrm>
-          <a:prstGeom prst="rect">
-            <a:avLst/>
-          </a:prstGeom>
-          <a:noFill/>
-          <a:ln/>
-        </p:spPr>
-        <p:txBody>
-          <a:bodyPr wrap="square" lIns="1524" tIns="1524" rIns="1524" bIns="1524" rtlCol="0" anchor="t"/>
-          <a:lstStyle/>
-          <a:p>
-            <a:pPr indent="0" marL="0">
-              <a:buNone/>
-            </a:pPr>
-            <a:r>
-              <a:rPr lang="en-US" sz="2000" b="1" dirty="0">
-                <a:solidFill>
-                  <a:schemeClr val="accent2"/>
-                </a:solidFill>
-              </a:rPr>
-              <a:t>02:00 UTC, 17 Oct 2026 · trigger = schedule</a:t>
-            </a:r>
-            <a:endParaRPr lang="en-US" sz="1500" dirty="0"/>
-          </a:p>
-          <a:p>
-            <a:pPr indent="0" marL="0">
-              <a:buNone/>
-            </a:pPr>
-            <a:r>
-              <a:rPr lang="en-US" sz="1500" dirty="0">
-                <a:solidFill>
-                  <a:schemeClr val="tx1"/>
-                </a:solidFill>
-              </a:rPr>
-              <a:t>All five tenants succeeded in 21 s: 999 new events ingested, 18 quarantined, 12 replays rejected, mean probability moved &lt; 0.002.</a:t>
-            </a:r>
-            <a:endParaRPr lang="en-US" sz="1500" dirty="0"/>
-          </a:p>
-        </p:txBody>
-      </p:sp>
-      <p:sp>
-        <p:nvSpPr>
-          <p:cNvPr id="19" name="Text 17"/>
-          <p:cNvSpPr txBox="1"/>
-          <p:nvPr/>
-        </p:nvSpPr>
-        <p:spPr>
-          <a:xfrm>
-            <a:off x="6400800" y="3291840"/>
-            <a:ext cx="5212080" cy="2926080"/>
-          </a:xfrm>
-          <a:prstGeom prst="rect">
-            <a:avLst/>
-          </a:prstGeom>
-          <a:noFill/>
-          <a:ln/>
-        </p:spPr>
-        <p:txBody>
-          <a:bodyPr wrap="square" lIns="1524" tIns="1524" rIns="1524" bIns="1524" rtlCol="0" anchor="t"/>
-          <a:lstStyle/>
-          <a:p>
-            <a:pPr indent="0" marL="0">
-              <a:buNone/>
-            </a:pPr>
-            <a:r>
-              <a:rPr lang="en-US" sz="1500" b="1" dirty="0">
-                <a:solidFill>
-                  <a:schemeClr val="tx1"/>
-                </a:solidFill>
-              </a:rPr>
-              <a:t>Rerun safe</a:t>
-            </a:r>
-            <a:endParaRPr lang="en-US" sz="1500" dirty="0"/>
-          </a:p>
-          <a:p>
-            <a:pPr indent="0" marL="0">
-              <a:buNone/>
-            </a:pPr>
-            <a:r>
-              <a:rPr lang="en-US" sz="1500" dirty="0">
-                <a:solidFill>
-                  <a:schemeClr val="tx1"/>
-                </a:solidFill>
-              </a:rPr>
-              <a:t>A succeeded night is a no-op; a failed one is re-claimed; every write is keyed.</a:t>
-            </a:r>
-            <a:endParaRPr lang="en-US" sz="1500" dirty="0"/>
-          </a:p>
-          <a:p>
-            <a:pPr indent="0" marL="0">
-              <a:buNone/>
-            </a:pPr>
-            <a:r>
-              <a:rPr lang="en-US" sz="1500" dirty="0">
-                <a:solidFill>
-                  <a:schemeClr val="tx1"/>
-                </a:solidFill>
-              </a:rPr>
-              <a:t> </a:t>
-            </a:r>
-            <a:endParaRPr lang="en-US" sz="1500" dirty="0"/>
-          </a:p>
-          <a:p>
-            <a:pPr indent="0" marL="0">
-              <a:buNone/>
-            </a:pPr>
-            <a:r>
-              <a:rPr lang="en-US" sz="1500" b="1" dirty="0">
-                <a:solidFill>
-                  <a:schemeClr val="tx1"/>
-                </a:solidFill>
-              </a:rPr>
-              <a:t>No flapping</a:t>
-            </a:r>
-            <a:endParaRPr lang="en-US" sz="1500" dirty="0"/>
-          </a:p>
-          <a:p>
-            <a:pPr indent="0" marL="0">
-              <a:buNone/>
-            </a:pPr>
-            <a:r>
-              <a:rPr lang="en-US" sz="1500" dirty="0">
-                <a:solidFill>
-                  <a:schemeClr val="tx1"/>
-                </a:solidFill>
-              </a:rPr>
-              <a:t>A task needs three nights outside the top 8 first; at most 8 new tasks per CSM per night.</a:t>
-            </a:r>
-            <a:endParaRPr lang="en-US" sz="1500" dirty="0"/>
-          </a:p>
-        </p:txBody>
-      </p:sp>
-      <p:sp>
-        <p:nvSpPr>
-          <p:cNvPr id="25" name="Slide Number Placeholder 0"/>
-          <p:cNvSpPr>
-            <a:spLocks noGrp="1"/>
-          </p:cNvSpPr>
-          <p:nvPr>
-            <p:ph type="sldNum" sz="quarter" idx="4294967295"/>
-          </p:nvPr>
-        </p:nvSpPr>
-        <p:spPr>
-          <a:xfrm>
-            <a:off x="11247120" y="6400800"/>
-            <a:ext cx="548640" cy="274320"/>
-          </a:xfrm>
-          <a:prstGeom prst="rect">
-            <a:avLst/>
-          </a:prstGeom>
-          <a:extLst>
-            <a:ext uri="{C572A759-6A51-4108-AA02-DFA0A04FC94B}">
-              <ma14:wrappingTextBoxFlag xmlns:ma14="http://schemas.microsoft.com/office/mac/drawingml/2011/main" val="0"/>
-            </a:ext>
-          </a:extLst>
-        </p:spPr>
-        <p:txBody>
-          <a:bodyPr/>
-          <a:lstStyle>
-            <a:lvl1pPr>
-              <a:defRPr sz="1000">
-                <a:solidFill>
-                  <a:schemeClr val="accent6"/>
-                </a:solidFill>
-              </a:defRPr>
-            </a:lvl1pPr>
-          </a:lstStyle>
-          <a:p>
-            <a:pPr algn="r"/>
-            <a:fld id="{F7021451-1387-4CA6-816F-3879F97B5CBC}" type="slidenum">
-              <a:rPr b="0" lang="en-US"/>
               <a:t>7</a:t>
             </a:fld>
             <a:endParaRPr lang="en-US"/>
@@ -6500,49 +6760,38 @@
                   <a:schemeClr val="tx1"/>
                 </a:solidFill>
               </a:rPr>
-              <a:t>What breaks first at 10x, measured</a:t>
+              <a:t>Beats rules and the calendar; ties logistic regression</a:t>
             </a:r>
             <a:endParaRPr lang="en-US" sz="3200" dirty="0"/>
           </a:p>
         </p:txBody>
       </p:sp>
-      <p:sp>
-        <p:nvSpPr>
-          <p:cNvPr id="3" name="axis 10x events"/>
-          <p:cNvSpPr/>
-          <p:nvPr/>
-        </p:nvSpPr>
-        <p:spPr>
-          <a:xfrm>
-            <a:off x="548640" y="1371600"/>
-            <a:ext cx="3520440" cy="2743200"/>
-          </a:xfrm>
-          <a:prstGeom prst="roundRect">
-            <a:avLst>
-              <a:gd name="adj" fmla="val 2667"/>
-            </a:avLst>
-          </a:prstGeom>
-          <a:solidFill>
-            <a:schemeClr val="bg2"/>
-          </a:solidFill>
-          <a:ln w="12700">
-            <a:solidFill>
-              <a:schemeClr val="bg2"/>
-            </a:solidFill>
-            <a:prstDash val="solid"/>
-          </a:ln>
-        </p:spPr>
-      </p:sp>
-      <p:sp>
-        <p:nvSpPr>
-          <p:cNvPr id="4" name="Text 2"/>
+      <p:graphicFrame>
+        <p:nvGraphicFramePr>
+          <p:cNvPr id="3" name="Chart 0" descr=""/>
+          <p:cNvGraphicFramePr/>
+          <p:nvPr/>
+        </p:nvGraphicFramePr>
+        <p:xfrm>
+          <a:off x="548640" y="1325880"/>
+          <a:ext cx="6766560" cy="4937760"/>
+        </p:xfrm>
+        <a:graphic xmlns:a="http://schemas.openxmlformats.org/drawingml/2006/main">
+          <a:graphicData uri="http://schemas.openxmlformats.org/drawingml/2006/chart">
+            <c:chart xmlns:c="http://schemas.openxmlformats.org/drawingml/2006/chart" r:id="rId1"/>
+          </a:graphicData>
+        </a:graphic>
+      </p:graphicFrame>
+      <p:sp>
+        <p:nvSpPr>
+          <p:cNvPr id="4" name="Text 1"/>
           <p:cNvSpPr txBox="1"/>
           <p:nvPr/>
         </p:nvSpPr>
         <p:spPr>
           <a:xfrm>
-            <a:off x="777240" y="1508760"/>
-            <a:ext cx="3063240" cy="457200"/>
+            <a:off x="7680960" y="1371600"/>
+            <a:ext cx="1737360" cy="914400"/>
           </a:xfrm>
           <a:prstGeom prst="rect">
             <a:avLst/>
@@ -6551,73 +6800,37 @@
           <a:ln/>
         </p:spPr>
         <p:txBody>
-          <a:bodyPr wrap="square" lIns="1524" tIns="1524" rIns="1524" bIns="1524" rtlCol="0" anchor="t"/>
+          <a:bodyPr wrap="square" lIns="1524" tIns="1524" rIns="1524" bIns="1524" rtlCol="0" anchor="ctr"/>
           <a:lstStyle/>
           <a:p>
             <a:pPr indent="0" marL="0">
               <a:buNone/>
             </a:pPr>
             <a:r>
-              <a:rPr lang="en-US" sz="1800" b="1" dirty="0">
-                <a:solidFill>
-                  <a:schemeClr val="accent3"/>
-                </a:solidFill>
-              </a:rPr>
-              <a:t>10x events</a:t>
-            </a:r>
-            <a:endParaRPr lang="en-US" sz="1800" dirty="0"/>
-          </a:p>
-        </p:txBody>
-      </p:sp>
-      <p:sp>
-        <p:nvSpPr>
-          <p:cNvPr id="5" name="Text 3"/>
-          <p:cNvSpPr txBox="1"/>
-          <p:nvPr/>
-        </p:nvSpPr>
-        <p:spPr>
-          <a:xfrm>
-            <a:off x="777240" y="1920240"/>
-            <a:ext cx="3063240" cy="914400"/>
-          </a:xfrm>
-          <a:prstGeom prst="rect">
-            <a:avLst/>
-          </a:prstGeom>
-          <a:noFill/>
-          <a:ln/>
-        </p:spPr>
-        <p:txBody>
-          <a:bodyPr wrap="square" lIns="1524" tIns="1524" rIns="1524" bIns="1524" rtlCol="0" anchor="ctr"/>
-          <a:lstStyle/>
-          <a:p>
-            <a:pPr indent="0" marL="0">
-              <a:buNone/>
-            </a:pPr>
-            <a:r>
-              <a:rPr lang="en-US" sz="4000" b="1" dirty="0">
-                <a:solidFill>
-                  <a:schemeClr val="tx1"/>
+              <a:rPr lang="en-US" sz="3000" b="1" dirty="0">
+                <a:solidFill>
+                  <a:schemeClr val="accent1"/>
                 </a:solidFill>
                 <a:latin typeface="Cambria" pitchFamily="34" charset="0"/>
                 <a:ea typeface="Cambria" pitchFamily="34" charset="-122"/>
                 <a:cs typeface="Cambria" pitchFamily="34" charset="-120"/>
               </a:rPr>
-              <a:t>~40 min</a:t>
-            </a:r>
-            <a:endParaRPr lang="en-US" sz="4000" dirty="0"/>
-          </a:p>
-        </p:txBody>
-      </p:sp>
-      <p:sp>
-        <p:nvSpPr>
-          <p:cNvPr id="6" name="Text 4"/>
+              <a:t>21.8%</a:t>
+            </a:r>
+            <a:endParaRPr lang="en-US" sz="3000" dirty="0"/>
+          </a:p>
+        </p:txBody>
+      </p:sp>
+      <p:sp>
+        <p:nvSpPr>
+          <p:cNvPr id="5" name="Text 2"/>
           <p:cNvSpPr txBox="1"/>
           <p:nvPr/>
         </p:nvSpPr>
         <p:spPr>
           <a:xfrm>
-            <a:off x="777240" y="2880360"/>
-            <a:ext cx="3063240" cy="1097280"/>
+            <a:off x="9418320" y="1417320"/>
+            <a:ext cx="2286000" cy="868680"/>
           </a:xfrm>
           <a:prstGeom prst="rect">
             <a:avLst/>
@@ -6626,7 +6839,7 @@
           <a:ln/>
         </p:spPr>
         <p:txBody>
-          <a:bodyPr wrap="square" lIns="1524" tIns="1524" rIns="1524" bIns="1524" rtlCol="0" anchor="t"/>
+          <a:bodyPr wrap="square" lIns="1524" tIns="1524" rIns="1524" bIns="1524" rtlCol="0" anchor="ctr"/>
           <a:lstStyle/>
           <a:p>
             <a:pPr indent="0" marL="0">
@@ -6638,7 +6851,7 @@
                   <a:schemeClr val="tx2"/>
                 </a:solidFill>
               </a:rPr>
-              <a:t>for one tenant's anchor build on the VM; peaks near 1 GB. Breaks first, on memory.</a:t>
+              <a:t>recall@8 per CSM-week (rules 14.8%)</a:t>
             </a:r>
             <a:endParaRPr lang="en-US" sz="1400" dirty="0"/>
           </a:p>
@@ -6646,41 +6859,14 @@
       </p:sp>
       <p:sp>
         <p:nvSpPr>
-          <p:cNvPr id="7" name="axis 10x accounts"/>
-          <p:cNvSpPr/>
-          <p:nvPr/>
-        </p:nvSpPr>
-        <p:spPr>
-          <a:xfrm>
-            <a:off x="4297680" y="1371600"/>
-            <a:ext cx="3520440" cy="2743200"/>
-          </a:xfrm>
-          <a:prstGeom prst="roundRect">
-            <a:avLst>
-              <a:gd name="adj" fmla="val 2667"/>
-            </a:avLst>
-          </a:prstGeom>
-          <a:solidFill>
-            <a:schemeClr val="bg2"/>
-          </a:solidFill>
-          <a:ln w="12700">
-            <a:solidFill>
-              <a:schemeClr val="bg2"/>
-            </a:solidFill>
-            <a:prstDash val="solid"/>
-          </a:ln>
-        </p:spPr>
-      </p:sp>
-      <p:sp>
-        <p:nvSpPr>
-          <p:cNvPr id="8" name="Text 6"/>
+          <p:cNvPr id="6" name="Text 3"/>
           <p:cNvSpPr txBox="1"/>
           <p:nvPr/>
         </p:nvSpPr>
         <p:spPr>
           <a:xfrm>
-            <a:off x="4526280" y="1508760"/>
-            <a:ext cx="3063240" cy="457200"/>
+            <a:off x="7680960" y="2606040"/>
+            <a:ext cx="1737360" cy="914400"/>
           </a:xfrm>
           <a:prstGeom prst="rect">
             <a:avLst/>
@@ -6689,73 +6875,37 @@
           <a:ln/>
         </p:spPr>
         <p:txBody>
-          <a:bodyPr wrap="square" lIns="1524" tIns="1524" rIns="1524" bIns="1524" rtlCol="0" anchor="t"/>
+          <a:bodyPr wrap="square" lIns="1524" tIns="1524" rIns="1524" bIns="1524" rtlCol="0" anchor="ctr"/>
           <a:lstStyle/>
           <a:p>
             <a:pPr indent="0" marL="0">
               <a:buNone/>
             </a:pPr>
             <a:r>
-              <a:rPr lang="en-US" sz="1800" b="1" dirty="0">
-                <a:solidFill>
-                  <a:schemeClr val="accent4"/>
-                </a:solidFill>
-              </a:rPr>
-              <a:t>10x accounts</a:t>
-            </a:r>
-            <a:endParaRPr lang="en-US" sz="1800" dirty="0"/>
-          </a:p>
-        </p:txBody>
-      </p:sp>
-      <p:sp>
-        <p:nvSpPr>
-          <p:cNvPr id="9" name="Text 7"/>
-          <p:cNvSpPr txBox="1"/>
-          <p:nvPr/>
-        </p:nvSpPr>
-        <p:spPr>
-          <a:xfrm>
-            <a:off x="4526280" y="1920240"/>
-            <a:ext cx="3063240" cy="914400"/>
-          </a:xfrm>
-          <a:prstGeom prst="rect">
-            <a:avLst/>
-          </a:prstGeom>
-          <a:noFill/>
-          <a:ln/>
-        </p:spPr>
-        <p:txBody>
-          <a:bodyPr wrap="square" lIns="1524" tIns="1524" rIns="1524" bIns="1524" rtlCol="0" anchor="ctr"/>
-          <a:lstStyle/>
-          <a:p>
-            <a:pPr indent="0" marL="0">
-              <a:buNone/>
-            </a:pPr>
-            <a:r>
-              <a:rPr lang="en-US" sz="4000" b="1" dirty="0">
-                <a:solidFill>
-                  <a:schemeClr val="tx1"/>
+              <a:rPr lang="en-US" sz="3000" b="1" dirty="0">
+                <a:solidFill>
+                  <a:schemeClr val="accent1"/>
                 </a:solidFill>
                 <a:latin typeface="Cambria" pitchFamily="34" charset="0"/>
                 <a:ea typeface="Cambria" pitchFamily="34" charset="-122"/>
                 <a:cs typeface="Cambria" pitchFamily="34" charset="-120"/>
               </a:rPr>
-              <a:t>~4.5 GB</a:t>
-            </a:r>
-            <a:endParaRPr lang="en-US" sz="4000" dirty="0"/>
-          </a:p>
-        </p:txBody>
-      </p:sp>
-      <p:sp>
-        <p:nvSpPr>
-          <p:cNvPr id="10" name="Text 8"/>
+              <a:t>+0.009</a:t>
+            </a:r>
+            <a:endParaRPr lang="en-US" sz="3000" dirty="0"/>
+          </a:p>
+        </p:txBody>
+      </p:sp>
+      <p:sp>
+        <p:nvSpPr>
+          <p:cNvPr id="7" name="Text 4"/>
           <p:cNvSpPr txBox="1"/>
           <p:nvPr/>
         </p:nvSpPr>
         <p:spPr>
           <a:xfrm>
-            <a:off x="4526280" y="2880360"/>
-            <a:ext cx="3063240" cy="1097280"/>
+            <a:off x="9418320" y="2651760"/>
+            <a:ext cx="2286000" cy="868680"/>
           </a:xfrm>
           <a:prstGeom prst="rect">
             <a:avLst/>
@@ -6764,7 +6914,7 @@
           <a:ln/>
         </p:spPr>
         <p:txBody>
-          <a:bodyPr wrap="square" lIns="1524" tIns="1524" rIns="1524" bIns="1524" rtlCol="0" anchor="t"/>
+          <a:bodyPr wrap="square" lIns="1524" tIns="1524" rIns="1524" bIns="1524" rtlCol="0" anchor="ctr"/>
           <a:lstStyle/>
           <a:p>
             <a:pPr indent="0" marL="0">
@@ -6776,7 +6926,7 @@
                   <a:schemeClr val="tx2"/>
                 </a:solidFill>
               </a:rPr>
-              <a:t>of snapshots, plus ~3 GB of scores a month. Disk binds within weeks.</a:t>
+              <a:t>LightGBM minus LR, 95% CI −0.009 to +0.028</a:t>
             </a:r>
             <a:endParaRPr lang="en-US" sz="1400" dirty="0"/>
           </a:p>
@@ -6784,41 +6934,14 @@
       </p:sp>
       <p:sp>
         <p:nvSpPr>
-          <p:cNvPr id="11" name="axis 10x tenants"/>
-          <p:cNvSpPr/>
-          <p:nvPr/>
-        </p:nvSpPr>
-        <p:spPr>
-          <a:xfrm>
-            <a:off x="8046720" y="1371600"/>
-            <a:ext cx="3520440" cy="2743200"/>
-          </a:xfrm>
-          <a:prstGeom prst="roundRect">
-            <a:avLst>
-              <a:gd name="adj" fmla="val 2667"/>
-            </a:avLst>
-          </a:prstGeom>
-          <a:solidFill>
-            <a:schemeClr val="bg2"/>
-          </a:solidFill>
-          <a:ln w="12700">
-            <a:solidFill>
-              <a:schemeClr val="bg2"/>
-            </a:solidFill>
-            <a:prstDash val="solid"/>
-          </a:ln>
-        </p:spPr>
-      </p:sp>
-      <p:sp>
-        <p:nvSpPr>
-          <p:cNvPr id="12" name="Text 10"/>
+          <p:cNvPr id="8" name="Text 5"/>
           <p:cNvSpPr txBox="1"/>
           <p:nvPr/>
         </p:nvSpPr>
         <p:spPr>
           <a:xfrm>
-            <a:off x="8275320" y="1508760"/>
-            <a:ext cx="3063240" cy="457200"/>
+            <a:off x="7680960" y="3840480"/>
+            <a:ext cx="1737360" cy="914400"/>
           </a:xfrm>
           <a:prstGeom prst="rect">
             <a:avLst/>
@@ -6827,73 +6950,37 @@
           <a:ln/>
         </p:spPr>
         <p:txBody>
-          <a:bodyPr wrap="square" lIns="1524" tIns="1524" rIns="1524" bIns="1524" rtlCol="0" anchor="t"/>
+          <a:bodyPr wrap="square" lIns="1524" tIns="1524" rIns="1524" bIns="1524" rtlCol="0" anchor="ctr"/>
           <a:lstStyle/>
           <a:p>
             <a:pPr indent="0" marL="0">
               <a:buNone/>
             </a:pPr>
             <a:r>
-              <a:rPr lang="en-US" sz="1800" b="1" dirty="0">
-                <a:solidFill>
-                  <a:schemeClr val="accent5"/>
-                </a:solidFill>
-              </a:rPr>
-              <a:t>10x tenants</a:t>
-            </a:r>
-            <a:endParaRPr lang="en-US" sz="1800" dirty="0"/>
-          </a:p>
-        </p:txBody>
-      </p:sp>
-      <p:sp>
-        <p:nvSpPr>
-          <p:cNvPr id="13" name="Text 11"/>
-          <p:cNvSpPr txBox="1"/>
-          <p:nvPr/>
-        </p:nvSpPr>
-        <p:spPr>
-          <a:xfrm>
-            <a:off x="8275320" y="1920240"/>
-            <a:ext cx="3063240" cy="914400"/>
-          </a:xfrm>
-          <a:prstGeom prst="rect">
-            <a:avLst/>
-          </a:prstGeom>
-          <a:noFill/>
-          <a:ln/>
-        </p:spPr>
-        <p:txBody>
-          <a:bodyPr wrap="square" lIns="1524" tIns="1524" rIns="1524" bIns="1524" rtlCol="0" anchor="ctr"/>
-          <a:lstStyle/>
-          <a:p>
-            <a:pPr indent="0" marL="0">
-              <a:buNone/>
-            </a:pPr>
-            <a:r>
-              <a:rPr lang="en-US" sz="4000" b="1" dirty="0">
-                <a:solidFill>
-                  <a:schemeClr val="tx1"/>
+              <a:rPr lang="en-US" sz="3000" b="1" dirty="0">
+                <a:solidFill>
+                  <a:schemeClr val="accent1"/>
                 </a:solidFill>
                 <a:latin typeface="Cambria" pitchFamily="34" charset="0"/>
                 <a:ea typeface="Cambria" pitchFamily="34" charset="-122"/>
                 <a:cs typeface="Cambria" pitchFamily="34" charset="-120"/>
               </a:rPr>
-              <a:t>~3.5 min</a:t>
-            </a:r>
-            <a:endParaRPr lang="en-US" sz="4000" dirty="0"/>
-          </a:p>
-        </p:txBody>
-      </p:sp>
-      <p:sp>
-        <p:nvSpPr>
-          <p:cNvPr id="14" name="Text 12"/>
+              <a:t>0.8%</a:t>
+            </a:r>
+            <a:endParaRPr lang="en-US" sz="3000" dirty="0"/>
+          </a:p>
+        </p:txBody>
+      </p:sp>
+      <p:sp>
+        <p:nvSpPr>
+          <p:cNvPr id="9" name="Text 6"/>
           <p:cNvSpPr txBox="1"/>
           <p:nvPr/>
         </p:nvSpPr>
         <p:spPr>
           <a:xfrm>
-            <a:off x="8275320" y="2880360"/>
-            <a:ext cx="3063240" cy="1097280"/>
+            <a:off x="9418320" y="3886200"/>
+            <a:ext cx="2286000" cy="868680"/>
           </a:xfrm>
           <a:prstGeom prst="rect">
             <a:avLst/>
@@ -6902,7 +6989,7 @@
           <a:ln/>
         </p:spPr>
         <p:txBody>
-          <a:bodyPr wrap="square" lIns="1524" tIns="1524" rIns="1524" bIns="1524" rtlCol="0" anchor="t"/>
+          <a:bodyPr wrap="square" lIns="1524" tIns="1524" rIns="1524" bIns="1524" rtlCol="0" anchor="ctr"/>
           <a:lstStyle/>
           <a:p>
             <a:pPr indent="0" marL="0">
@@ -6914,7 +7001,7 @@
                   <a:schemeClr val="tx2"/>
                 </a:solidFill>
               </a:rPr>
-              <a:t>for the nightly loop: fine. Bootstrap and training memory bind instead.</a:t>
+              <a:t>share of the model that is days to renewal</a:t>
             </a:r>
             <a:endParaRPr lang="en-US" sz="1400" dirty="0"/>
           </a:p>
@@ -6922,14 +7009,14 @@
       </p:sp>
       <p:sp>
         <p:nvSpPr>
-          <p:cNvPr id="15" name="Text 13"/>
+          <p:cNvPr id="10" name="Text 7"/>
           <p:cNvSpPr txBox="1"/>
           <p:nvPr/>
         </p:nvSpPr>
         <p:spPr>
           <a:xfrm>
-            <a:off x="548640" y="4480560"/>
-            <a:ext cx="11064240" cy="1280160"/>
+            <a:off x="7680960" y="5074920"/>
+            <a:ext cx="1737360" cy="914400"/>
           </a:xfrm>
           <a:prstGeom prst="rect">
             <a:avLst/>
@@ -6938,21 +7025,60 @@
           <a:ln/>
         </p:spPr>
         <p:txBody>
-          <a:bodyPr wrap="square" lIns="1524" tIns="1524" rIns="1524" bIns="1524" rtlCol="0" anchor="t"/>
+          <a:bodyPr wrap="square" lIns="1524" tIns="1524" rIns="1524" bIns="1524" rtlCol="0" anchor="ctr"/>
           <a:lstStyle/>
           <a:p>
             <a:pPr indent="0" marL="0">
               <a:buNone/>
             </a:pPr>
             <a:r>
-              <a:rPr lang="en-US" sz="1600" dirty="0">
-                <a:solidFill>
-                  <a:schemeClr val="tx1"/>
-                </a:solidFill>
-              </a:rPr>
-              <a:t>Today: the whole night takes 21 s. Snapshot ~0.05 ms per event, scoring ~1 ms per account. The plan's hypothesis held, sharpened: the weekly anchor rebuild is O(weeks x events) and runs out of memory before time. Fix: incremental anchors from running aggregates, then retention and a per-tenant queue.</a:t>
-            </a:r>
-            <a:endParaRPr lang="en-US" sz="1600" dirty="0"/>
+              <a:rPr lang="en-US" sz="3000" b="1" dirty="0">
+                <a:solidFill>
+                  <a:schemeClr val="accent1"/>
+                </a:solidFill>
+                <a:latin typeface="Cambria" pitchFamily="34" charset="0"/>
+                <a:ea typeface="Cambria" pitchFamily="34" charset="-122"/>
+                <a:cs typeface="Cambria" pitchFamily="34" charset="-120"/>
+              </a:rPr>
+              <a:t>0.48</a:t>
+            </a:r>
+            <a:endParaRPr lang="en-US" sz="3000" dirty="0"/>
+          </a:p>
+        </p:txBody>
+      </p:sp>
+      <p:sp>
+        <p:nvSpPr>
+          <p:cNvPr id="11" name="Text 8"/>
+          <p:cNvSpPr txBox="1"/>
+          <p:nvPr/>
+        </p:nvSpPr>
+        <p:spPr>
+          <a:xfrm>
+            <a:off x="9418320" y="5120640"/>
+            <a:ext cx="2286000" cy="868680"/>
+          </a:xfrm>
+          <a:prstGeom prst="rect">
+            <a:avLst/>
+          </a:prstGeom>
+          <a:noFill/>
+          <a:ln/>
+        </p:spPr>
+        <p:txBody>
+          <a:bodyPr wrap="square" lIns="1524" tIns="1524" rIns="1524" bIns="1524" rtlCol="0" anchor="ctr"/>
+          <a:lstStyle/>
+          <a:p>
+            <a:pPr indent="0" marL="0">
+              <a:buNone/>
+            </a:pPr>
+            <a:r>
+              <a:rPr lang="en-US" sz="1400" dirty="0">
+                <a:solidFill>
+                  <a:schemeClr val="tx2"/>
+                </a:solidFill>
+              </a:rPr>
+              <a:t>shuffled-label AUC: no leakage</a:t>
+            </a:r>
+            <a:endParaRPr lang="en-US" sz="1400" dirty="0"/>
           </a:p>
         </p:txBody>
       </p:sp>
@@ -7036,8 +7162,8 @@
         </p:nvSpPr>
         <p:spPr>
           <a:xfrm>
-            <a:off x="731520" y="2011680"/>
-            <a:ext cx="10698480" cy="1645920"/>
+            <a:off x="548640" y="320040"/>
+            <a:ext cx="11064240" cy="822960"/>
           </a:xfrm>
           <a:prstGeom prst="rect">
             <a:avLst/>
@@ -7046,36 +7172,61 @@
           <a:ln/>
         </p:spPr>
         <p:txBody>
-          <a:bodyPr wrap="square" rtlCol="0" anchor="b"/>
+          <a:bodyPr wrap="square" rtlCol="0" anchor="ctr"/>
           <a:lstStyle/>
           <a:p>
             <a:pPr algn="l" indent="0" marL="0">
               <a:buNone/>
             </a:pPr>
             <a:r>
-              <a:rPr lang="en-US" sz="4400" b="1" dirty="0">
-                <a:solidFill>
-                  <a:schemeClr val="bg1"/>
-                </a:solidFill>
-              </a:rPr>
-              <a:t>With real data, the first four steps</a:t>
-            </a:r>
-            <a:endParaRPr lang="en-US" sz="4400" dirty="0"/>
-          </a:p>
-        </p:txBody>
-      </p:sp>
-      <p:sp>
-        <p:nvSpPr>
-          <p:cNvPr id="3" name="Text 0"/>
+              <a:rPr lang="en-US" sz="3200" b="1" dirty="0">
+                <a:solidFill>
+                  <a:schemeClr val="tx1"/>
+                </a:solidFill>
+              </a:rPr>
+              <a:t>The night runs itself, and every step is a row</a:t>
+            </a:r>
+            <a:endParaRPr lang="en-US" sz="3200" dirty="0"/>
+          </a:p>
+        </p:txBody>
+      </p:sp>
+      <p:sp>
+        <p:nvSpPr>
+          <p:cNvPr id="3" name="stage Ingest"/>
           <p:cNvSpPr/>
-          <p:nvPr>
-            <p:ph idx="101" type="body" hasCustomPrompt="1"/>
-          </p:nvPr>
-        </p:nvSpPr>
-        <p:spPr>
-          <a:xfrm>
-            <a:off x="731520" y="3794760"/>
-            <a:ext cx="10698480" cy="1463040"/>
+          <p:nvPr/>
+        </p:nvSpPr>
+        <p:spPr>
+          <a:xfrm>
+            <a:off x="548640" y="1463040"/>
+            <a:ext cx="1417320" cy="822960"/>
+          </a:xfrm>
+          <a:prstGeom prst="roundRect">
+            <a:avLst>
+              <a:gd name="adj" fmla="val 8889"/>
+            </a:avLst>
+          </a:prstGeom>
+          <a:solidFill>
+            <a:schemeClr val="tx2"/>
+          </a:solidFill>
+          <a:ln w="12700">
+            <a:solidFill>
+              <a:schemeClr val="tx2"/>
+            </a:solidFill>
+            <a:prstDash val="solid"/>
+          </a:ln>
+        </p:spPr>
+      </p:sp>
+      <p:sp>
+        <p:nvSpPr>
+          <p:cNvPr id="4" name="Text 2"/>
+          <p:cNvSpPr txBox="1"/>
+          <p:nvPr/>
+        </p:nvSpPr>
+        <p:spPr>
+          <a:xfrm>
+            <a:off x="548640" y="1463040"/>
+            <a:ext cx="1417320" cy="822960"/>
           </a:xfrm>
           <a:prstGeom prst="rect">
             <a:avLst/>
@@ -7084,63 +7235,622 @@
           <a:ln/>
         </p:spPr>
         <p:txBody>
-          <a:bodyPr wrap="square" rtlCol="0" anchor="t"/>
-          <a:lstStyle/>
-          <a:p>
-            <a:pPr algn="l" indent="0" marL="0">
-              <a:buNone/>
-            </a:pPr>
-            <a:r>
-              <a:rPr lang="en-US" sz="1800" dirty="0">
-                <a:solidFill>
-                  <a:schemeClr val="bg2"/>
-                </a:solidFill>
-              </a:rPr>
-              <a:t>1. Refit and re-baseline on real renewal outcomes; report the same holdout tables.</a:t>
-            </a:r>
-            <a:endParaRPr lang="en-US" sz="1800" dirty="0"/>
-          </a:p>
-          <a:p>
-            <a:pPr algn="l" indent="0" marL="0">
-              <a:buNone/>
-            </a:pPr>
-            <a:r>
-              <a:rPr lang="en-US" sz="1800" dirty="0">
-                <a:solidFill>
-                  <a:schemeClr val="bg2"/>
-                </a:solidFill>
-              </a:rPr>
-              <a:t>2. Use CSM dismissal reasons as labels and as a precision signal for K.</a:t>
-            </a:r>
-            <a:endParaRPr lang="en-US" sz="1800" dirty="0"/>
-          </a:p>
-          <a:p>
-            <a:pPr algn="l" indent="0" marL="0">
-              <a:buNone/>
-            </a:pPr>
-            <a:r>
-              <a:rPr lang="en-US" sz="1800" dirty="0">
-                <a:solidFill>
-                  <a:schemeClr val="bg2"/>
-                </a:solidFill>
-              </a:rPr>
-              <a:t>3. Build anchors incrementally, so history scales with events, not weeks x events.</a:t>
-            </a:r>
-            <a:endParaRPr lang="en-US" sz="1800" dirty="0"/>
-          </a:p>
-          <a:p>
-            <a:pPr algn="l" indent="0" marL="0">
-              <a:buNone/>
-            </a:pPr>
-            <a:r>
-              <a:rPr lang="en-US" sz="1800" dirty="0">
-                <a:solidFill>
-                  <a:schemeClr val="bg2"/>
-                </a:solidFill>
-              </a:rPr>
-              <a:t>4. Add identity confidence, and connectors that write the same raw-event shape.</a:t>
-            </a:r>
-            <a:endParaRPr lang="en-US" sz="1800" dirty="0"/>
+          <a:bodyPr wrap="square" lIns="635" tIns="635" rIns="635" bIns="635" rtlCol="0" anchor="ctr"/>
+          <a:lstStyle/>
+          <a:p>
+            <a:pPr algn="ctr" indent="0" marL="0">
+              <a:buNone/>
+            </a:pPr>
+            <a:r>
+              <a:rPr lang="en-US" sz="1400" b="1" dirty="0">
+                <a:solidFill>
+                  <a:schemeClr val="bg1"/>
+                </a:solidFill>
+              </a:rPr>
+              <a:t>Ingest</a:t>
+            </a:r>
+            <a:endParaRPr lang="en-US" sz="1400" dirty="0"/>
+          </a:p>
+        </p:txBody>
+      </p:sp>
+      <p:sp>
+        <p:nvSpPr>
+          <p:cNvPr id="5" name="stage Snapshot"/>
+          <p:cNvSpPr/>
+          <p:nvPr/>
+        </p:nvSpPr>
+        <p:spPr>
+          <a:xfrm>
+            <a:off x="2148840" y="1463040"/>
+            <a:ext cx="1417320" cy="822960"/>
+          </a:xfrm>
+          <a:prstGeom prst="roundRect">
+            <a:avLst>
+              <a:gd name="adj" fmla="val 8889"/>
+            </a:avLst>
+          </a:prstGeom>
+          <a:solidFill>
+            <a:schemeClr val="tx2"/>
+          </a:solidFill>
+          <a:ln w="12700">
+            <a:solidFill>
+              <a:schemeClr val="tx2"/>
+            </a:solidFill>
+            <a:prstDash val="solid"/>
+          </a:ln>
+        </p:spPr>
+      </p:sp>
+      <p:sp>
+        <p:nvSpPr>
+          <p:cNvPr id="6" name="Text 4"/>
+          <p:cNvSpPr txBox="1"/>
+          <p:nvPr/>
+        </p:nvSpPr>
+        <p:spPr>
+          <a:xfrm>
+            <a:off x="2148840" y="1463040"/>
+            <a:ext cx="1417320" cy="822960"/>
+          </a:xfrm>
+          <a:prstGeom prst="rect">
+            <a:avLst/>
+          </a:prstGeom>
+          <a:noFill/>
+          <a:ln/>
+        </p:spPr>
+        <p:txBody>
+          <a:bodyPr wrap="square" lIns="635" tIns="635" rIns="635" bIns="635" rtlCol="0" anchor="ctr"/>
+          <a:lstStyle/>
+          <a:p>
+            <a:pPr algn="ctr" indent="0" marL="0">
+              <a:buNone/>
+            </a:pPr>
+            <a:r>
+              <a:rPr lang="en-US" sz="1400" b="1" dirty="0">
+                <a:solidFill>
+                  <a:schemeClr val="bg1"/>
+                </a:solidFill>
+              </a:rPr>
+              <a:t>Snapshot</a:t>
+            </a:r>
+            <a:endParaRPr lang="en-US" sz="1400" dirty="0"/>
+          </a:p>
+        </p:txBody>
+      </p:sp>
+      <p:sp>
+        <p:nvSpPr>
+          <p:cNvPr id="7" name="stage Score"/>
+          <p:cNvSpPr/>
+          <p:nvPr/>
+        </p:nvSpPr>
+        <p:spPr>
+          <a:xfrm>
+            <a:off x="3749040" y="1463040"/>
+            <a:ext cx="1417320" cy="822960"/>
+          </a:xfrm>
+          <a:prstGeom prst="roundRect">
+            <a:avLst>
+              <a:gd name="adj" fmla="val 8889"/>
+            </a:avLst>
+          </a:prstGeom>
+          <a:solidFill>
+            <a:schemeClr val="tx2"/>
+          </a:solidFill>
+          <a:ln w="12700">
+            <a:solidFill>
+              <a:schemeClr val="tx2"/>
+            </a:solidFill>
+            <a:prstDash val="solid"/>
+          </a:ln>
+        </p:spPr>
+      </p:sp>
+      <p:sp>
+        <p:nvSpPr>
+          <p:cNvPr id="8" name="Text 6"/>
+          <p:cNvSpPr txBox="1"/>
+          <p:nvPr/>
+        </p:nvSpPr>
+        <p:spPr>
+          <a:xfrm>
+            <a:off x="3749040" y="1463040"/>
+            <a:ext cx="1417320" cy="822960"/>
+          </a:xfrm>
+          <a:prstGeom prst="rect">
+            <a:avLst/>
+          </a:prstGeom>
+          <a:noFill/>
+          <a:ln/>
+        </p:spPr>
+        <p:txBody>
+          <a:bodyPr wrap="square" lIns="635" tIns="635" rIns="635" bIns="635" rtlCol="0" anchor="ctr"/>
+          <a:lstStyle/>
+          <a:p>
+            <a:pPr algn="ctr" indent="0" marL="0">
+              <a:buNone/>
+            </a:pPr>
+            <a:r>
+              <a:rPr lang="en-US" sz="1400" b="1" dirty="0">
+                <a:solidFill>
+                  <a:schemeClr val="bg1"/>
+                </a:solidFill>
+              </a:rPr>
+              <a:t>Score</a:t>
+            </a:r>
+            <a:endParaRPr lang="en-US" sz="1400" dirty="0"/>
+          </a:p>
+        </p:txBody>
+      </p:sp>
+      <p:sp>
+        <p:nvSpPr>
+          <p:cNvPr id="9" name="stage Gate"/>
+          <p:cNvSpPr/>
+          <p:nvPr/>
+        </p:nvSpPr>
+        <p:spPr>
+          <a:xfrm>
+            <a:off x="5349240" y="1463040"/>
+            <a:ext cx="1417320" cy="822960"/>
+          </a:xfrm>
+          <a:prstGeom prst="roundRect">
+            <a:avLst>
+              <a:gd name="adj" fmla="val 8889"/>
+            </a:avLst>
+          </a:prstGeom>
+          <a:solidFill>
+            <a:schemeClr val="accent1"/>
+          </a:solidFill>
+          <a:ln w="12700">
+            <a:solidFill>
+              <a:schemeClr val="accent1"/>
+            </a:solidFill>
+            <a:prstDash val="solid"/>
+          </a:ln>
+        </p:spPr>
+      </p:sp>
+      <p:sp>
+        <p:nvSpPr>
+          <p:cNvPr id="10" name="Text 8"/>
+          <p:cNvSpPr txBox="1"/>
+          <p:nvPr/>
+        </p:nvSpPr>
+        <p:spPr>
+          <a:xfrm>
+            <a:off x="5349240" y="1463040"/>
+            <a:ext cx="1417320" cy="822960"/>
+          </a:xfrm>
+          <a:prstGeom prst="rect">
+            <a:avLst/>
+          </a:prstGeom>
+          <a:noFill/>
+          <a:ln/>
+        </p:spPr>
+        <p:txBody>
+          <a:bodyPr wrap="square" lIns="635" tIns="635" rIns="635" bIns="635" rtlCol="0" anchor="ctr"/>
+          <a:lstStyle/>
+          <a:p>
+            <a:pPr algn="ctr" indent="0" marL="0">
+              <a:buNone/>
+            </a:pPr>
+            <a:r>
+              <a:rPr lang="en-US" sz="1400" b="1" dirty="0">
+                <a:solidFill>
+                  <a:schemeClr val="bg1"/>
+                </a:solidFill>
+              </a:rPr>
+              <a:t>Gate</a:t>
+            </a:r>
+            <a:endParaRPr lang="en-US" sz="1400" dirty="0"/>
+          </a:p>
+        </p:txBody>
+      </p:sp>
+      <p:sp>
+        <p:nvSpPr>
+          <p:cNvPr id="11" name="stage Transitions"/>
+          <p:cNvSpPr/>
+          <p:nvPr/>
+        </p:nvSpPr>
+        <p:spPr>
+          <a:xfrm>
+            <a:off x="6949440" y="1463040"/>
+            <a:ext cx="1417320" cy="822960"/>
+          </a:xfrm>
+          <a:prstGeom prst="roundRect">
+            <a:avLst>
+              <a:gd name="adj" fmla="val 8889"/>
+            </a:avLst>
+          </a:prstGeom>
+          <a:solidFill>
+            <a:schemeClr val="tx2"/>
+          </a:solidFill>
+          <a:ln w="12700">
+            <a:solidFill>
+              <a:schemeClr val="tx2"/>
+            </a:solidFill>
+            <a:prstDash val="solid"/>
+          </a:ln>
+        </p:spPr>
+      </p:sp>
+      <p:sp>
+        <p:nvSpPr>
+          <p:cNvPr id="12" name="Text 10"/>
+          <p:cNvSpPr txBox="1"/>
+          <p:nvPr/>
+        </p:nvSpPr>
+        <p:spPr>
+          <a:xfrm>
+            <a:off x="6949440" y="1463040"/>
+            <a:ext cx="1417320" cy="822960"/>
+          </a:xfrm>
+          <a:prstGeom prst="rect">
+            <a:avLst/>
+          </a:prstGeom>
+          <a:noFill/>
+          <a:ln/>
+        </p:spPr>
+        <p:txBody>
+          <a:bodyPr wrap="square" lIns="635" tIns="635" rIns="635" bIns="635" rtlCol="0" anchor="ctr"/>
+          <a:lstStyle/>
+          <a:p>
+            <a:pPr algn="ctr" indent="0" marL="0">
+              <a:buNone/>
+            </a:pPr>
+            <a:r>
+              <a:rPr lang="en-US" sz="1400" b="1" dirty="0">
+                <a:solidFill>
+                  <a:schemeClr val="bg1"/>
+                </a:solidFill>
+              </a:rPr>
+              <a:t>Transitions</a:t>
+            </a:r>
+            <a:endParaRPr lang="en-US" sz="1400" dirty="0"/>
+          </a:p>
+        </p:txBody>
+      </p:sp>
+      <p:sp>
+        <p:nvSpPr>
+          <p:cNvPr id="13" name="stage Policy + tasks"/>
+          <p:cNvSpPr/>
+          <p:nvPr/>
+        </p:nvSpPr>
+        <p:spPr>
+          <a:xfrm>
+            <a:off x="8549640" y="1463040"/>
+            <a:ext cx="1417320" cy="822960"/>
+          </a:xfrm>
+          <a:prstGeom prst="roundRect">
+            <a:avLst>
+              <a:gd name="adj" fmla="val 8889"/>
+            </a:avLst>
+          </a:prstGeom>
+          <a:solidFill>
+            <a:schemeClr val="tx2"/>
+          </a:solidFill>
+          <a:ln w="12700">
+            <a:solidFill>
+              <a:schemeClr val="tx2"/>
+            </a:solidFill>
+            <a:prstDash val="solid"/>
+          </a:ln>
+        </p:spPr>
+      </p:sp>
+      <p:sp>
+        <p:nvSpPr>
+          <p:cNvPr id="14" name="Text 12"/>
+          <p:cNvSpPr txBox="1"/>
+          <p:nvPr/>
+        </p:nvSpPr>
+        <p:spPr>
+          <a:xfrm>
+            <a:off x="8549640" y="1463040"/>
+            <a:ext cx="1417320" cy="822960"/>
+          </a:xfrm>
+          <a:prstGeom prst="rect">
+            <a:avLst/>
+          </a:prstGeom>
+          <a:noFill/>
+          <a:ln/>
+        </p:spPr>
+        <p:txBody>
+          <a:bodyPr wrap="square" lIns="635" tIns="635" rIns="635" bIns="635" rtlCol="0" anchor="ctr"/>
+          <a:lstStyle/>
+          <a:p>
+            <a:pPr algn="ctr" indent="0" marL="0">
+              <a:buNone/>
+            </a:pPr>
+            <a:r>
+              <a:rPr lang="en-US" sz="1400" b="1" dirty="0">
+                <a:solidFill>
+                  <a:schemeClr val="bg1"/>
+                </a:solidFill>
+              </a:rPr>
+              <a:t>Policy + tasks</a:t>
+            </a:r>
+            <a:endParaRPr lang="en-US" sz="1400" dirty="0"/>
+          </a:p>
+        </p:txBody>
+      </p:sp>
+      <p:sp>
+        <p:nvSpPr>
+          <p:cNvPr id="15" name="stage Escalation"/>
+          <p:cNvSpPr/>
+          <p:nvPr/>
+        </p:nvSpPr>
+        <p:spPr>
+          <a:xfrm>
+            <a:off x="10149840" y="1463040"/>
+            <a:ext cx="1417320" cy="822960"/>
+          </a:xfrm>
+          <a:prstGeom prst="roundRect">
+            <a:avLst>
+              <a:gd name="adj" fmla="val 8889"/>
+            </a:avLst>
+          </a:prstGeom>
+          <a:solidFill>
+            <a:schemeClr val="tx2"/>
+          </a:solidFill>
+          <a:ln w="12700">
+            <a:solidFill>
+              <a:schemeClr val="tx2"/>
+            </a:solidFill>
+            <a:prstDash val="solid"/>
+          </a:ln>
+        </p:spPr>
+      </p:sp>
+      <p:sp>
+        <p:nvSpPr>
+          <p:cNvPr id="16" name="Text 14"/>
+          <p:cNvSpPr txBox="1"/>
+          <p:nvPr/>
+        </p:nvSpPr>
+        <p:spPr>
+          <a:xfrm>
+            <a:off x="10149840" y="1463040"/>
+            <a:ext cx="1417320" cy="822960"/>
+          </a:xfrm>
+          <a:prstGeom prst="rect">
+            <a:avLst/>
+          </a:prstGeom>
+          <a:noFill/>
+          <a:ln/>
+        </p:spPr>
+        <p:txBody>
+          <a:bodyPr wrap="square" lIns="635" tIns="635" rIns="635" bIns="635" rtlCol="0" anchor="ctr"/>
+          <a:lstStyle/>
+          <a:p>
+            <a:pPr algn="ctr" indent="0" marL="0">
+              <a:buNone/>
+            </a:pPr>
+            <a:r>
+              <a:rPr lang="en-US" sz="1400" b="1" dirty="0">
+                <a:solidFill>
+                  <a:schemeClr val="bg1"/>
+                </a:solidFill>
+              </a:rPr>
+              <a:t>Escalation</a:t>
+            </a:r>
+            <a:endParaRPr lang="en-US" sz="1400" dirty="0"/>
+          </a:p>
+        </p:txBody>
+      </p:sp>
+      <p:sp>
+        <p:nvSpPr>
+          <p:cNvPr id="17" name="Text 15"/>
+          <p:cNvSpPr txBox="1"/>
+          <p:nvPr/>
+        </p:nvSpPr>
+        <p:spPr>
+          <a:xfrm>
+            <a:off x="548640" y="2468880"/>
+            <a:ext cx="11064240" cy="640080"/>
+          </a:xfrm>
+          <a:prstGeom prst="rect">
+            <a:avLst/>
+          </a:prstGeom>
+          <a:noFill/>
+          <a:ln/>
+        </p:spPr>
+        <p:txBody>
+          <a:bodyPr wrap="square" lIns="1524" tIns="1524" rIns="1524" bIns="1524" rtlCol="0" anchor="t"/>
+          <a:lstStyle/>
+          <a:p>
+            <a:pPr indent="0" marL="0">
+              <a:buNone/>
+            </a:pPr>
+            <a:r>
+              <a:rPr lang="en-US" sz="1500" dirty="0">
+                <a:solidFill>
+                  <a:schemeClr val="tx2"/>
+                </a:solidFill>
+              </a:rPr>
+              <a:t>A tripped data-quality gate rolls the night back: nothing after it is published, and the list keeps the last good night with a warning.</a:t>
+            </a:r>
+            <a:endParaRPr lang="en-US" sz="1500" dirty="0"/>
+          </a:p>
+        </p:txBody>
+      </p:sp>
+      <p:sp>
+        <p:nvSpPr>
+          <p:cNvPr id="18" name="Text 16"/>
+          <p:cNvSpPr txBox="1"/>
+          <p:nvPr/>
+        </p:nvSpPr>
+        <p:spPr>
+          <a:xfrm>
+            <a:off x="548640" y="3291840"/>
+            <a:ext cx="5486400" cy="2377440"/>
+          </a:xfrm>
+          <a:prstGeom prst="rect">
+            <a:avLst/>
+          </a:prstGeom>
+          <a:noFill/>
+          <a:ln/>
+        </p:spPr>
+        <p:txBody>
+          <a:bodyPr wrap="square" lIns="1524" tIns="1524" rIns="1524" bIns="1524" rtlCol="0" anchor="t"/>
+          <a:lstStyle/>
+          <a:p>
+            <a:pPr indent="0" marL="0">
+              <a:buNone/>
+            </a:pPr>
+            <a:r>
+              <a:rPr lang="en-US" sz="2000" b="1" dirty="0">
+                <a:solidFill>
+                  <a:schemeClr val="accent2"/>
+                </a:solidFill>
+              </a:rPr>
+              <a:t>02:00 UTC, 17 Oct 2026 · trigger = schedule</a:t>
+            </a:r>
+            <a:endParaRPr lang="en-US" sz="1500" dirty="0"/>
+          </a:p>
+          <a:p>
+            <a:pPr indent="0" marL="0">
+              <a:buNone/>
+            </a:pPr>
+            <a:r>
+              <a:rPr lang="en-US" sz="1500" dirty="0">
+                <a:solidFill>
+                  <a:schemeClr val="tx1"/>
+                </a:solidFill>
+              </a:rPr>
+              <a:t>All five tenants succeeded in 21 s: 999 new events ingested, 18 quarantined, 12 replays rejected, mean probability moved &lt; 0.002.</a:t>
+            </a:r>
+            <a:endParaRPr lang="en-US" sz="1500" dirty="0"/>
+          </a:p>
+        </p:txBody>
+      </p:sp>
+      <p:sp>
+        <p:nvSpPr>
+          <p:cNvPr id="19" name="Text 17"/>
+          <p:cNvSpPr txBox="1"/>
+          <p:nvPr/>
+        </p:nvSpPr>
+        <p:spPr>
+          <a:xfrm>
+            <a:off x="6400800" y="3291840"/>
+            <a:ext cx="5212080" cy="2926080"/>
+          </a:xfrm>
+          <a:prstGeom prst="rect">
+            <a:avLst/>
+          </a:prstGeom>
+          <a:noFill/>
+          <a:ln/>
+        </p:spPr>
+        <p:txBody>
+          <a:bodyPr wrap="square" lIns="1524" tIns="1524" rIns="1524" bIns="1524" rtlCol="0" anchor="t"/>
+          <a:lstStyle/>
+          <a:p>
+            <a:pPr indent="0" marL="0">
+              <a:buNone/>
+            </a:pPr>
+            <a:r>
+              <a:rPr lang="en-US" sz="1500" b="1" dirty="0">
+                <a:solidFill>
+                  <a:schemeClr val="tx1"/>
+                </a:solidFill>
+              </a:rPr>
+              <a:t>Rerun safe</a:t>
+            </a:r>
+            <a:endParaRPr lang="en-US" sz="1500" dirty="0"/>
+          </a:p>
+          <a:p>
+            <a:pPr indent="0" marL="0">
+              <a:buNone/>
+            </a:pPr>
+            <a:r>
+              <a:rPr lang="en-US" sz="1500" dirty="0">
+                <a:solidFill>
+                  <a:schemeClr val="tx1"/>
+                </a:solidFill>
+              </a:rPr>
+              <a:t>A succeeded night is a no-op; a failed one is re-claimed; every write is keyed.</a:t>
+            </a:r>
+            <a:endParaRPr lang="en-US" sz="1500" dirty="0"/>
+          </a:p>
+          <a:p>
+            <a:pPr indent="0" marL="0">
+              <a:buNone/>
+            </a:pPr>
+            <a:r>
+              <a:rPr lang="en-US" sz="1500" dirty="0">
+                <a:solidFill>
+                  <a:schemeClr val="tx1"/>
+                </a:solidFill>
+              </a:rPr>
+              <a:t> </a:t>
+            </a:r>
+            <a:endParaRPr lang="en-US" sz="1500" dirty="0"/>
+          </a:p>
+          <a:p>
+            <a:pPr indent="0" marL="0">
+              <a:buNone/>
+            </a:pPr>
+            <a:r>
+              <a:rPr lang="en-US" sz="1500" b="1" dirty="0">
+                <a:solidFill>
+                  <a:schemeClr val="tx1"/>
+                </a:solidFill>
+              </a:rPr>
+              <a:t>No flapping</a:t>
+            </a:r>
+            <a:endParaRPr lang="en-US" sz="1500" dirty="0"/>
+          </a:p>
+          <a:p>
+            <a:pPr indent="0" marL="0">
+              <a:buNone/>
+            </a:pPr>
+            <a:r>
+              <a:rPr lang="en-US" sz="1500" dirty="0">
+                <a:solidFill>
+                  <a:schemeClr val="tx1"/>
+                </a:solidFill>
+              </a:rPr>
+              <a:t>A task needs three nights outside the top 8 first; at most 8 new tasks per CSM per night.</a:t>
+            </a:r>
+            <a:endParaRPr lang="en-US" sz="1500" dirty="0"/>
+          </a:p>
+        </p:txBody>
+      </p:sp>
+      <p:sp>
+        <p:nvSpPr>
+          <p:cNvPr id="25" name="Slide Number Placeholder 0"/>
+          <p:cNvSpPr>
+            <a:spLocks noGrp="1"/>
+          </p:cNvSpPr>
+          <p:nvPr>
+            <p:ph type="sldNum" sz="quarter" idx="4294967295"/>
+          </p:nvPr>
+        </p:nvSpPr>
+        <p:spPr>
+          <a:xfrm>
+            <a:off x="11247120" y="6400800"/>
+            <a:ext cx="548640" cy="274320"/>
+          </a:xfrm>
+          <a:prstGeom prst="rect">
+            <a:avLst/>
+          </a:prstGeom>
+          <a:extLst>
+            <a:ext uri="{C572A759-6A51-4108-AA02-DFA0A04FC94B}">
+              <ma14:wrappingTextBoxFlag xmlns:ma14="http://schemas.microsoft.com/office/mac/drawingml/2011/main" val="0"/>
+            </a:ext>
+          </a:extLst>
+        </p:spPr>
+        <p:txBody>
+          <a:bodyPr/>
+          <a:lstStyle>
+            <a:lvl1pPr>
+              <a:defRPr sz="1000">
+                <a:solidFill>
+                  <a:schemeClr val="accent6"/>
+                </a:solidFill>
+              </a:defRPr>
+            </a:lvl1pPr>
+          </a:lstStyle>
+          <a:p>
+            <a:pPr algn="r"/>
+            <a:fld id="{F7021451-1387-4CA6-816F-3879F97B5CBC}" type="slidenum">
+              <a:rPr b="0" lang="en-US"/>
+              <a:t>9</a:t>
+            </a:fld>
+            <a:endParaRPr lang="en-US"/>
           </a:p>
         </p:txBody>
       </p:sp>

</xml_diff>